<commit_message>
RA2-AA2: explica com funciona la paritat del RAID 5 (analogia amb sumes i XOR) al temari T02 i en una diapositiva nova
Co-Authored-By: Claude Opus 5.5 <noreply@anthropic.com>
Claude-Session: https://claude.ai/code/session_01BodJZ9PsepvknsFhsdyYkP
</commit_message>
<xml_diff>
--- a/RA2 - Emmagatzematge i copies de seguretat/AA2 - Sistemes demmagatzematge/RA2_AA2_Sistemes_emmagatzematge.pptx
+++ b/RA2 - Emmagatzematge i copies de seguretat/AA2 - Sistemes demmagatzematge/RA2_AA2_Sistemes_emmagatzematge.pptx
@@ -20,6 +20,7 @@
     <p:sldId id="275" r:id="rId26"/>
     <p:sldId id="263" r:id="rId9"/>
     <p:sldId id="276" r:id="rId27"/>
+    <p:sldId id="286" r:id="rId37"/>
     <p:sldId id="264" r:id="rId10"/>
     <p:sldId id="277" r:id="rId28"/>
     <p:sldId id="265" r:id="rId11"/>
@@ -4908,7 +4909,7 @@
                 <a:ea typeface="Calibri" pitchFamily="34" charset="-122"/>
                 <a:cs typeface="Calibri" pitchFamily="34" charset="-120"/>
               </a:rPr>
-              <a:t>16</a:t>
+              <a:t>17</a:t>
             </a:r>
             <a:endParaRPr lang="en-US" sz="1100" dirty="0"/>
           </a:p>
@@ -5432,7 +5433,7 @@
                   <a:srgbClr val="5B6B77"/>
                 </a:solidFill>
               </a:rPr>
-              <a:t>17</a:t>
+              <a:t>18</a:t>
             </a:r>
           </a:p>
         </p:txBody>
@@ -5580,7 +5581,7 @@
                 <a:ea typeface="Calibri" pitchFamily="34" charset="-122"/>
                 <a:cs typeface="Calibri" pitchFamily="34" charset="-120"/>
               </a:rPr>
-              <a:t>18</a:t>
+              <a:t>19</a:t>
             </a:r>
             <a:endParaRPr lang="en-US" sz="1100" dirty="0"/>
           </a:p>
@@ -8695,7 +8696,7 @@
                 <a:ea typeface="Calibri" pitchFamily="34" charset="-122"/>
                 <a:cs typeface="Calibri" pitchFamily="34" charset="-120"/>
               </a:rPr>
-              <a:t>19</a:t>
+              <a:t>20</a:t>
             </a:r>
             <a:endParaRPr lang="en-US" sz="1100" dirty="0"/>
           </a:p>
@@ -9755,7 +9756,7 @@
                 <a:ea typeface="Calibri" pitchFamily="34" charset="-122"/>
                 <a:cs typeface="Calibri" pitchFamily="34" charset="-120"/>
               </a:rPr>
-              <a:t>20</a:t>
+              <a:t>21</a:t>
             </a:r>
             <a:endParaRPr lang="en-US" sz="1100" dirty="0"/>
           </a:p>
@@ -10348,7 +10349,7 @@
                   <a:srgbClr val="5B6B77"/>
                 </a:solidFill>
               </a:rPr>
-              <a:t>21</a:t>
+              <a:t>22</a:t>
             </a:r>
           </a:p>
         </p:txBody>
@@ -10496,7 +10497,7 @@
                 <a:ea typeface="Calibri" pitchFamily="34" charset="-122"/>
                 <a:cs typeface="Calibri" pitchFamily="34" charset="-120"/>
               </a:rPr>
-              <a:t>22</a:t>
+              <a:t>23</a:t>
             </a:r>
             <a:endParaRPr lang="en-US" sz="1100" dirty="0"/>
           </a:p>
@@ -11020,7 +11021,7 @@
                   <a:srgbClr val="5B6B77"/>
                 </a:solidFill>
               </a:rPr>
-              <a:t>23</a:t>
+              <a:t>24</a:t>
             </a:r>
           </a:p>
         </p:txBody>
@@ -11168,7 +11169,7 @@
                 <a:ea typeface="Calibri" pitchFamily="34" charset="-122"/>
                 <a:cs typeface="Calibri" pitchFamily="34" charset="-120"/>
               </a:rPr>
-              <a:t>24</a:t>
+              <a:t>25</a:t>
             </a:r>
             <a:endParaRPr lang="en-US" sz="1100" dirty="0"/>
           </a:p>
@@ -11554,7 +11555,7 @@
                   <a:srgbClr val="5B6B77"/>
                 </a:solidFill>
               </a:rPr>
-              <a:t>25</a:t>
+              <a:t>26</a:t>
             </a:r>
           </a:p>
         </p:txBody>
@@ -11702,7 +11703,7 @@
                 <a:ea typeface="Calibri" pitchFamily="34" charset="-122"/>
                 <a:cs typeface="Calibri" pitchFamily="34" charset="-120"/>
               </a:rPr>
-              <a:t>26</a:t>
+              <a:t>27</a:t>
             </a:r>
             <a:endParaRPr lang="en-US" sz="1100" dirty="0"/>
           </a:p>
@@ -12006,7 +12007,7 @@
                 <a:ea typeface="Calibri" pitchFamily="34" charset="-122"/>
                 <a:cs typeface="Calibri" pitchFamily="34" charset="-120"/>
               </a:rPr>
-              <a:t>27</a:t>
+              <a:t>28</a:t>
             </a:r>
             <a:endParaRPr lang="en-US" sz="1100" dirty="0"/>
           </a:p>
@@ -13731,7 +13732,7 @@
                 <a:ea typeface="Calibri" pitchFamily="34" charset="-122"/>
                 <a:cs typeface="Calibri" pitchFamily="34" charset="-120"/>
               </a:rPr>
-              <a:t>28</a:t>
+              <a:t>29</a:t>
             </a:r>
             <a:endParaRPr lang="en-US" sz="1100" dirty="0"/>
           </a:p>
@@ -14653,7 +14654,7 @@
                 <a:ea typeface="Calibri" pitchFamily="34" charset="-122"/>
                 <a:cs typeface="Calibri" pitchFamily="34" charset="-120"/>
               </a:rPr>
-              <a:t>29</a:t>
+              <a:t>30</a:t>
             </a:r>
             <a:endParaRPr lang="en-US" sz="1100" dirty="0"/>
           </a:p>
@@ -15721,9 +15722,642 @@
                 <a:ea typeface="Calibri" pitchFamily="34" charset="-122"/>
                 <a:cs typeface="Calibri" pitchFamily="34" charset="-120"/>
               </a:rPr>
-              <a:t>30</a:t>
+              <a:t>31</a:t>
             </a:r>
             <a:endParaRPr lang="en-US" sz="1100" dirty="0"/>
+          </a:p>
+        </p:txBody>
+      </p:sp>
+    </p:spTree>
+  </p:cSld>
+  <p:clrMapOvr>
+    <a:masterClrMapping/>
+  </p:clrMapOvr>
+</p:sld>
+</file>
+
+<file path=ppt/slides/slide31.xml><?xml version="1.0" encoding="utf-8"?>
+<p:sld xmlns:a="http://schemas.openxmlformats.org/drawingml/2006/main" xmlns:p="http://schemas.openxmlformats.org/presentationml/2006/main" xmlns:r="http://schemas.openxmlformats.org/officeDocument/2006/relationships">
+  <p:cSld>
+    <p:bg>
+      <p:bgPr>
+        <a:solidFill>
+          <a:srgbClr val="F4F7F9"/>
+        </a:solidFill>
+      </p:bgPr>
+    </p:bg>
+    <p:spTree>
+      <p:nvGrpSpPr>
+        <p:cNvPr id="1" name=""/>
+        <p:cNvGrpSpPr/>
+        <p:nvPr/>
+      </p:nvGrpSpPr>
+      <p:grpSpPr/>
+      <p:sp>
+        <p:nvSpPr>
+          <p:cNvPr id="2" name="Text 0"/>
+          <p:cNvSpPr txBox="1"/>
+          <p:nvPr/>
+        </p:nvSpPr>
+        <p:spPr>
+          <a:xfrm>
+            <a:off x="548640" y="457200"/>
+            <a:ext cx="9144000" cy="365760"/>
+          </a:xfrm>
+          <a:prstGeom prst="rect">
+            <a:avLst/>
+          </a:prstGeom>
+          <a:noFill/>
+          <a:ln/>
+        </p:spPr>
+        <p:txBody>
+          <a:bodyPr wrap="square" lIns="0" tIns="0" rIns="0" bIns="0" rtlCol="0" anchor="ctr"/>
+          <a:lstStyle/>
+          <a:p>
+            <a:pPr indent="0" marL="0">
+              <a:buNone/>
+            </a:pPr>
+            <a:r>
+              <a:rPr lang="en-US" sz="1300" b="1" spc="200" kern="0" dirty="0">
+                <a:solidFill>
+                  <a:srgbClr val="F2A541"/>
+                </a:solidFill>
+                <a:latin typeface="Calibri" pitchFamily="34" charset="0"/>
+                <a:ea typeface="Calibri" pitchFamily="34" charset="-122"/>
+                <a:cs typeface="Calibri" pitchFamily="34" charset="-120"/>
+              </a:rPr>
+              <a:t>RAID 5 · LA PARITAT</a:t>
+            </a:r>
+            <a:endParaRPr lang="en-US" sz="1300" dirty="0"/>
+          </a:p>
+        </p:txBody>
+      </p:sp>
+      <p:sp>
+        <p:nvSpPr>
+          <p:cNvPr id="3" name="Text 1"/>
+          <p:cNvSpPr txBox="1"/>
+          <p:nvPr/>
+        </p:nvSpPr>
+        <p:spPr>
+          <a:xfrm>
+            <a:off x="548640" y="822960"/>
+            <a:ext cx="10789920" cy="640080"/>
+          </a:xfrm>
+          <a:prstGeom prst="rect">
+            <a:avLst/>
+          </a:prstGeom>
+          <a:noFill/>
+          <a:ln/>
+        </p:spPr>
+        <p:txBody>
+          <a:bodyPr wrap="square" lIns="0" tIns="0" rIns="0" bIns="0" rtlCol="0" anchor="ctr"/>
+          <a:lstStyle/>
+          <a:p>
+            <a:pPr indent="0" marL="0">
+              <a:buNone/>
+            </a:pPr>
+            <a:r>
+              <a:rPr lang="en-US" sz="2800" b="1" dirty="0">
+                <a:solidFill>
+                  <a:srgbClr val="16242E"/>
+                </a:solidFill>
+                <a:latin typeface="Cambria" pitchFamily="34" charset="0"/>
+                <a:ea typeface="Cambria" pitchFamily="34" charset="-122"/>
+                <a:cs typeface="Cambria" pitchFamily="34" charset="-120"/>
+              </a:rPr>
+              <a:t>Com funciona la paritat?</a:t>
+            </a:r>
+            <a:endParaRPr lang="en-US" sz="2800" dirty="0"/>
+          </a:p>
+        </p:txBody>
+      </p:sp>
+      <p:sp>
+        <p:nvSpPr>
+          <p:cNvPr id="4" name="Text 2"/>
+          <p:cNvSpPr txBox="1"/>
+          <p:nvPr/>
+        </p:nvSpPr>
+        <p:spPr>
+          <a:xfrm>
+            <a:off x="11551615" y="6446520"/>
+            <a:ext cx="457200" cy="274320"/>
+          </a:xfrm>
+          <a:prstGeom prst="rect">
+            <a:avLst/>
+          </a:prstGeom>
+          <a:noFill/>
+          <a:ln/>
+        </p:spPr>
+        <p:txBody>
+          <a:bodyPr wrap="square" lIns="0" tIns="0" rIns="0" bIns="0" rtlCol="0" anchor="ctr"/>
+          <a:lstStyle/>
+          <a:p>
+            <a:pPr algn="r" indent="0" marL="0">
+              <a:buNone/>
+            </a:pPr>
+            <a:r>
+              <a:rPr lang="en-US" sz="1100" dirty="0">
+                <a:solidFill>
+                  <a:srgbClr val="5B6B77"/>
+                </a:solidFill>
+                <a:latin typeface="Calibri" pitchFamily="34" charset="0"/>
+                <a:ea typeface="Calibri" pitchFamily="34" charset="-122"/>
+                <a:cs typeface="Calibri" pitchFamily="34" charset="-120"/>
+              </a:rPr>
+              <a:t>16</a:t>
+            </a:r>
+            <a:endParaRPr lang="en-US" sz="1100" dirty="0"/>
+          </a:p>
+        </p:txBody>
+      </p:sp>
+      <p:sp>
+        <p:nvSpPr>
+          <p:cNvPr id="5" name="Shape 3"/>
+          <p:cNvSpPr/>
+          <p:nvPr/>
+        </p:nvSpPr>
+        <p:spPr>
+          <a:xfrm>
+            <a:off x="655168" y="1661160"/>
+            <a:ext cx="5212080" cy="4279392"/>
+          </a:xfrm>
+          <a:prstGeom prst="roundRect">
+            <a:avLst>
+              <a:gd name="adj" fmla="val 2791"/>
+            </a:avLst>
+          </a:prstGeom>
+          <a:solidFill>
+            <a:srgbClr val="FFFFFF"/>
+          </a:solidFill>
+          <a:ln w="12700">
+            <a:solidFill>
+              <a:srgbClr val="E2E8ED"/>
+            </a:solidFill>
+            <a:prstDash val="solid"/>
+          </a:ln>
+          <a:effectLst>
+            <a:outerShdw sx="100000" sy="100000" kx="0" ky="0" algn="bl" rotWithShape="0" blurRad="101600" dist="38100" dir="5400000">
+              <a:srgbClr val="16242E">
+                <a:alpha val="12000"/>
+              </a:srgbClr>
+            </a:outerShdw>
+          </a:effectLst>
+        </p:spPr>
+        <p:txBody>
+          <a:bodyPr/>
+          <a:p/>
+        </p:txBody>
+      </p:sp>
+      <p:sp>
+        <p:nvSpPr>
+          <p:cNvPr id="6" name="Shape 4"/>
+          <p:cNvSpPr/>
+          <p:nvPr/>
+        </p:nvSpPr>
+        <p:spPr>
+          <a:xfrm>
+            <a:off x="1039216" y="2045208"/>
+            <a:ext cx="731520" cy="731520"/>
+          </a:xfrm>
+          <a:prstGeom prst="ellipse">
+            <a:avLst/>
+          </a:prstGeom>
+          <a:solidFill>
+            <a:srgbClr val="0B1B29"/>
+          </a:solidFill>
+          <a:ln/>
+        </p:spPr>
+        <p:txBody>
+          <a:bodyPr/>
+          <a:p/>
+        </p:txBody>
+      </p:sp>
+      <p:pic>
+        <p:nvPicPr>
+          <p:cNvPr id="7" name="Image 0" descr="/tmp/claude-0/-home-user-SMX-0226-Seguretat-Informatica/a92ac1fc-9241-54c9-9c87-68470d7a571f/scratchpad/aa2/icon_heartbeat.png">    </p:cNvPr>
+          <p:cNvPicPr>
+            <a:picLocks noChangeAspect="1"/>
+          </p:cNvPicPr>
+          <p:nvPr/>
+        </p:nvPicPr>
+        <p:blipFill>
+          <a:blip r:embed="rId4"/>
+          <a:stretch>
+            <a:fillRect/>
+          </a:stretch>
+        </p:blipFill>
+        <p:spPr>
+          <a:xfrm>
+            <a:off x="1203808" y="2209800"/>
+            <a:ext cx="402336" cy="402336"/>
+          </a:xfrm>
+          <a:prstGeom prst="rect">
+            <a:avLst/>
+          </a:prstGeom>
+        </p:spPr>
+      </p:pic>
+      <p:sp>
+        <p:nvSpPr>
+          <p:cNvPr id="8" name="Text 5"/>
+          <p:cNvSpPr txBox="1"/>
+          <p:nvPr/>
+        </p:nvSpPr>
+        <p:spPr>
+          <a:xfrm>
+            <a:off x="1999336" y="2243328"/>
+            <a:ext cx="3483864" cy="335280"/>
+          </a:xfrm>
+          <a:prstGeom prst="rect">
+            <a:avLst/>
+          </a:prstGeom>
+          <a:noFill/>
+          <a:ln/>
+        </p:spPr>
+        <p:txBody>
+          <a:bodyPr wrap="square" lIns="0" tIns="0" rIns="0" bIns="0" rtlCol="0" anchor="ctr"/>
+          <a:lstStyle/>
+          <a:p>
+            <a:pPr indent="0" marL="0">
+              <a:buNone/>
+            </a:pPr>
+            <a:r>
+              <a:rPr lang="en-US" sz="2200" b="1" dirty="0">
+                <a:solidFill>
+                  <a:srgbClr val="16242E"/>
+                </a:solidFill>
+                <a:latin typeface="Cambria" pitchFamily="34" charset="0"/>
+                <a:ea typeface="Cambria" pitchFamily="34" charset="-122"/>
+                <a:cs typeface="Cambria" pitchFamily="34" charset="-120"/>
+              </a:rPr>
+              <a:t>Analogia amb sumes</a:t>
+            </a:r>
+            <a:endParaRPr lang="en-US" sz="2200" dirty="0"/>
+          </a:p>
+        </p:txBody>
+      </p:sp>
+      <p:sp>
+        <p:nvSpPr>
+          <p:cNvPr id="9" name="Text 6"/>
+          <p:cNvSpPr txBox="1"/>
+          <p:nvPr/>
+        </p:nvSpPr>
+        <p:spPr>
+          <a:xfrm>
+            <a:off x="1039216" y="3069336"/>
+            <a:ext cx="4443984" cy="2176272"/>
+          </a:xfrm>
+          <a:prstGeom prst="rect">
+            <a:avLst/>
+          </a:prstGeom>
+          <a:noFill/>
+          <a:ln/>
+        </p:spPr>
+        <p:txBody>
+          <a:bodyPr wrap="square" lIns="0" tIns="0" rIns="0" bIns="0" rtlCol="0" anchor="t"/>
+          <a:lstStyle/>
+          <a:p>
+            <a:pPr indent="0" marL="0">
+              <a:lnSpc>
+                <a:spcPts val="2448"/>
+              </a:lnSpc>
+              <a:buNone/>
+            </a:pPr>
+            <a:r>
+              <a:rPr lang="en-US" sz="1800" dirty="0" b="0">
+                <a:solidFill>
+                  <a:srgbClr val="5B6B77"/>
+                </a:solidFill>
+                <a:latin typeface="Calibri" pitchFamily="34" charset="0"/>
+                <a:ea typeface="Calibri" pitchFamily="34" charset="-122"/>
+                <a:cs typeface="Calibri" pitchFamily="34" charset="-120"/>
+              </a:rPr>
+              <a:t>Caixa A = 3, caixa B = 5 i, a la caixa C, la paritat: 3 + 5 = 8.</a:t>
+            </a:r>
+            <a:endParaRPr lang="en-US" sz="1800" dirty="0"/>
+          </a:p>
+          <a:p>
+            <a:pPr indent="0" marL="0">
+              <a:lnSpc>
+                <a:spcPts val="2448"/>
+              </a:lnSpc>
+              <a:buNone/>
+            </a:pPr>
+            <a:r>
+              <a:rPr lang="en-US" sz="1800" dirty="0" b="0">
+                <a:solidFill>
+                  <a:srgbClr val="5B6B77"/>
+                </a:solidFill>
+                <a:latin typeface="Calibri" pitchFamily="34" charset="0"/>
+                <a:ea typeface="Calibri" pitchFamily="34" charset="-122"/>
+                <a:cs typeface="Calibri" pitchFamily="34" charset="-120"/>
+              </a:rPr>
+              <a:t>Es perd A → 8 − 5 = 3</a:t>
+            </a:r>
+            <a:endParaRPr lang="en-US" sz="1800" dirty="0"/>
+          </a:p>
+          <a:p>
+            <a:pPr indent="0" marL="0">
+              <a:lnSpc>
+                <a:spcPts val="2448"/>
+              </a:lnSpc>
+              <a:buNone/>
+            </a:pPr>
+            <a:r>
+              <a:rPr lang="en-US" sz="1800" dirty="0" b="0">
+                <a:solidFill>
+                  <a:srgbClr val="5B6B77"/>
+                </a:solidFill>
+                <a:latin typeface="Calibri" pitchFamily="34" charset="0"/>
+                <a:ea typeface="Calibri" pitchFamily="34" charset="-122"/>
+                <a:cs typeface="Calibri" pitchFamily="34" charset="-120"/>
+              </a:rPr>
+              <a:t>Es perd B → 8 − 3 = 5</a:t>
+            </a:r>
+            <a:endParaRPr lang="en-US" sz="1800" dirty="0"/>
+          </a:p>
+          <a:p>
+            <a:pPr indent="0" marL="0">
+              <a:lnSpc>
+                <a:spcPts val="2448"/>
+              </a:lnSpc>
+              <a:buNone/>
+            </a:pPr>
+            <a:r>
+              <a:rPr lang="en-US" sz="1800" dirty="0" b="0">
+                <a:solidFill>
+                  <a:srgbClr val="5B6B77"/>
+                </a:solidFill>
+                <a:latin typeface="Calibri" pitchFamily="34" charset="0"/>
+                <a:ea typeface="Calibri" pitchFamily="34" charset="-122"/>
+                <a:cs typeface="Calibri" pitchFamily="34" charset="-120"/>
+              </a:rPr>
+              <a:t>Es perd C → 3 + 5 = 8</a:t>
+            </a:r>
+            <a:endParaRPr lang="en-US" sz="1800" dirty="0"/>
+          </a:p>
+          <a:p>
+            <a:pPr indent="0" marL="0">
+              <a:lnSpc>
+                <a:spcPts val="2448"/>
+              </a:lnSpc>
+              <a:buNone/>
+            </a:pPr>
+            <a:r>
+              <a:rPr lang="en-US" sz="1800" dirty="0" b="1">
+                <a:solidFill>
+                  <a:srgbClr val="5B6B77"/>
+                </a:solidFill>
+                <a:latin typeface="Calibri" pitchFamily="34" charset="0"/>
+                <a:ea typeface="Calibri" pitchFamily="34" charset="-122"/>
+                <a:cs typeface="Calibri" pitchFamily="34" charset="-120"/>
+              </a:rPr>
+              <a:t>Es perden dues caixes → impossible: el RAID 5 només suporta 1 fallada.</a:t>
+            </a:r>
+            <a:endParaRPr lang="en-US" sz="1800" dirty="0"/>
+          </a:p>
+        </p:txBody>
+      </p:sp>
+      <p:sp>
+        <p:nvSpPr>
+          <p:cNvPr id="10" name="Shape 7"/>
+          <p:cNvSpPr/>
+          <p:nvPr/>
+        </p:nvSpPr>
+        <p:spPr>
+          <a:xfrm>
+            <a:off x="6324448" y="1661160"/>
+            <a:ext cx="5212080" cy="4279392"/>
+          </a:xfrm>
+          <a:prstGeom prst="roundRect">
+            <a:avLst>
+              <a:gd name="adj" fmla="val 2791"/>
+            </a:avLst>
+          </a:prstGeom>
+          <a:solidFill>
+            <a:srgbClr val="FFFFFF"/>
+          </a:solidFill>
+          <a:ln w="12700">
+            <a:solidFill>
+              <a:srgbClr val="E2E8ED"/>
+            </a:solidFill>
+            <a:prstDash val="solid"/>
+          </a:ln>
+          <a:effectLst>
+            <a:outerShdw sx="100000" sy="100000" kx="0" ky="0" algn="bl" rotWithShape="0" blurRad="101600" dist="38100" dir="5400000">
+              <a:srgbClr val="16242E">
+                <a:alpha val="12000"/>
+              </a:srgbClr>
+            </a:outerShdw>
+          </a:effectLst>
+        </p:spPr>
+        <p:txBody>
+          <a:bodyPr/>
+          <a:p/>
+        </p:txBody>
+      </p:sp>
+      <p:sp>
+        <p:nvSpPr>
+          <p:cNvPr id="11" name="Shape 8"/>
+          <p:cNvSpPr/>
+          <p:nvPr/>
+        </p:nvSpPr>
+        <p:spPr>
+          <a:xfrm>
+            <a:off x="6708496" y="2045208"/>
+            <a:ext cx="731520" cy="731520"/>
+          </a:xfrm>
+          <a:prstGeom prst="ellipse">
+            <a:avLst/>
+          </a:prstGeom>
+          <a:solidFill>
+            <a:srgbClr val="0B1B29"/>
+          </a:solidFill>
+          <a:ln/>
+        </p:spPr>
+        <p:txBody>
+          <a:bodyPr/>
+          <a:p/>
+        </p:txBody>
+      </p:sp>
+      <p:pic>
+        <p:nvPicPr>
+          <p:cNvPr id="12" name="Image 1" descr="/tmp/claude-0/-home-user-SMX-0226-Seguretat-Informatica/a92ac1fc-9241-54c9-9c87-68470d7a571f/scratchpad/aa2/icon_terminal.png">    </p:cNvPr>
+          <p:cNvPicPr>
+            <a:picLocks noChangeAspect="1"/>
+          </p:cNvPicPr>
+          <p:nvPr/>
+        </p:nvPicPr>
+        <p:blipFill>
+          <a:blip r:embed="rId3"/>
+          <a:stretch>
+            <a:fillRect/>
+          </a:stretch>
+        </p:blipFill>
+        <p:spPr>
+          <a:xfrm>
+            <a:off x="6873087" y="2209800"/>
+            <a:ext cx="402336" cy="402336"/>
+          </a:xfrm>
+          <a:prstGeom prst="rect">
+            <a:avLst/>
+          </a:prstGeom>
+        </p:spPr>
+      </p:pic>
+      <p:sp>
+        <p:nvSpPr>
+          <p:cNvPr id="13" name="Text 9"/>
+          <p:cNvSpPr txBox="1"/>
+          <p:nvPr/>
+        </p:nvSpPr>
+        <p:spPr>
+          <a:xfrm>
+            <a:off x="7668616" y="2243328"/>
+            <a:ext cx="3483864" cy="335280"/>
+          </a:xfrm>
+          <a:prstGeom prst="rect">
+            <a:avLst/>
+          </a:prstGeom>
+          <a:noFill/>
+          <a:ln/>
+        </p:spPr>
+        <p:txBody>
+          <a:bodyPr wrap="square" lIns="0" tIns="0" rIns="0" bIns="0" rtlCol="0" anchor="ctr"/>
+          <a:lstStyle/>
+          <a:p>
+            <a:pPr indent="0" marL="0">
+              <a:buNone/>
+            </a:pPr>
+            <a:r>
+              <a:rPr lang="en-US" sz="2200" b="1" dirty="0">
+                <a:solidFill>
+                  <a:srgbClr val="16242E"/>
+                </a:solidFill>
+                <a:latin typeface="Cambria" pitchFamily="34" charset="0"/>
+                <a:ea typeface="Cambria" pitchFamily="34" charset="-122"/>
+                <a:cs typeface="Cambria" pitchFamily="34" charset="-120"/>
+              </a:rPr>
+              <a:t>Amb bits: l'operació XOR</a:t>
+            </a:r>
+            <a:endParaRPr lang="en-US" sz="2200" dirty="0"/>
+          </a:p>
+        </p:txBody>
+      </p:sp>
+      <p:sp>
+        <p:nvSpPr>
+          <p:cNvPr id="14" name="Text 10"/>
+          <p:cNvSpPr txBox="1"/>
+          <p:nvPr/>
+        </p:nvSpPr>
+        <p:spPr>
+          <a:xfrm>
+            <a:off x="6708496" y="3069336"/>
+            <a:ext cx="4443984" cy="2487168"/>
+          </a:xfrm>
+          <a:prstGeom prst="rect">
+            <a:avLst/>
+          </a:prstGeom>
+          <a:noFill/>
+          <a:ln/>
+        </p:spPr>
+        <p:txBody>
+          <a:bodyPr wrap="square" lIns="0" tIns="0" rIns="0" bIns="0" rtlCol="0" anchor="t"/>
+          <a:lstStyle/>
+          <a:p>
+            <a:pPr indent="0" marL="0">
+              <a:lnSpc>
+                <a:spcPts val="2448"/>
+              </a:lnSpc>
+              <a:buNone/>
+            </a:pPr>
+            <a:r>
+              <a:rPr lang="en-US" sz="1800" dirty="0" b="0">
+                <a:solidFill>
+                  <a:srgbClr val="5B6B77"/>
+                </a:solidFill>
+                <a:ea typeface="Calibri" pitchFamily="34" charset="-122"/>
+                <a:latin typeface="Consolas"/>
+              </a:rPr>
+              <a:t>Disc 1:   1 0 1 1</a:t>
+            </a:r>
+            <a:endParaRPr lang="en-US" sz="1800" dirty="0"/>
+          </a:p>
+          <a:p>
+            <a:pPr indent="0" marL="0">
+              <a:lnSpc>
+                <a:spcPts val="2448"/>
+              </a:lnSpc>
+              <a:buNone/>
+            </a:pPr>
+            <a:r>
+              <a:rPr lang="en-US" sz="1800" dirty="0" b="0">
+                <a:solidFill>
+                  <a:srgbClr val="5B6B77"/>
+                </a:solidFill>
+                <a:ea typeface="Calibri" pitchFamily="34" charset="-122"/>
+                <a:latin typeface="Consolas"/>
+              </a:rPr>
+              <a:t>Disc 2:   0 1 1 0</a:t>
+            </a:r>
+            <a:endParaRPr lang="en-US" sz="1800" dirty="0"/>
+          </a:p>
+          <a:p>
+            <a:pPr indent="0" marL="0">
+              <a:lnSpc>
+                <a:spcPts val="2448"/>
+              </a:lnSpc>
+              <a:buNone/>
+            </a:pPr>
+            <a:r>
+              <a:rPr lang="en-US" sz="1800" dirty="0" b="1">
+                <a:solidFill>
+                  <a:srgbClr val="5B6B77"/>
+                </a:solidFill>
+                <a:ea typeface="Calibri" pitchFamily="34" charset="-122"/>
+                <a:latin typeface="Consolas"/>
+              </a:rPr>
+              <a:t>Paritat:  1 1 0 1</a:t>
+            </a:r>
+            <a:endParaRPr lang="en-US" sz="1800" dirty="0"/>
+          </a:p>
+          <a:p>
+            <a:pPr indent="0" marL="0">
+              <a:lnSpc>
+                <a:spcPts val="2448"/>
+              </a:lnSpc>
+              <a:buNone/>
+            </a:pPr>
+            <a:r>
+              <a:rPr lang="en-US" sz="1800" dirty="0" b="0">
+                <a:solidFill>
+                  <a:srgbClr val="5B6B77"/>
+                </a:solidFill>
+                <a:latin typeface="Calibri" pitchFamily="34" charset="0"/>
+                <a:ea typeface="Calibri" pitchFamily="34" charset="-122"/>
+                <a:cs typeface="Calibri" pitchFamily="34" charset="-120"/>
+              </a:rPr>
+              <a:t>XOR: 1 si els bits són diferents, 0 si són iguals.</a:t>
+            </a:r>
+            <a:endParaRPr lang="en-US" sz="1800" dirty="0"/>
+          </a:p>
+          <a:p>
+            <a:pPr indent="0" marL="0">
+              <a:lnSpc>
+                <a:spcPts val="2448"/>
+              </a:lnSpc>
+              <a:buNone/>
+            </a:pPr>
+            <a:r>
+              <a:rPr lang="en-US" sz="1800" dirty="0" b="1">
+                <a:solidFill>
+                  <a:srgbClr val="5B6B77"/>
+                </a:solidFill>
+                <a:latin typeface="Calibri" pitchFamily="34" charset="0"/>
+                <a:ea typeface="Calibri" pitchFamily="34" charset="-122"/>
+                <a:cs typeface="Calibri" pitchFamily="34" charset="-120"/>
+              </a:rPr>
+              <a:t>Si falla el disc 1: disc 2 XOR paritat = 1 0 1 1 → recuperat.</a:t>
+            </a:r>
+            <a:endParaRPr lang="en-US" sz="1800" dirty="0"/>
           </a:p>
         </p:txBody>
       </p:sp>

</xml_diff>

<commit_message>
RA2-AA2: aclareix el model híbrid (ampliar l'espai o la potència només quan cal) al temari T02 i a la diapositiva 28
Co-Authored-By: Claude Opus 5.5 <noreply@anthropic.com>
Claude-Session: https://claude.ai/code/session_01BodJZ9PsepvknsFhsdyYkP
</commit_message>
<xml_diff>
--- a/RA2 - Emmagatzematge i copies de seguretat/AA2 - Sistemes demmagatzematge/RA2_AA2_Sistemes_emmagatzematge.pptx
+++ b/RA2 - Emmagatzematge i copies de seguretat/AA2 - Sistemes demmagatzematge/RA2_AA2_Sistemes_emmagatzematge.pptx
@@ -4775,6 +4775,639 @@
 </file>
 
 <file path=ppt/slides/slide16.xml><?xml version="1.0" encoding="utf-8"?>
+<p:sld xmlns:a="http://schemas.openxmlformats.org/drawingml/2006/main" xmlns:p="http://schemas.openxmlformats.org/presentationml/2006/main" xmlns:r="http://schemas.openxmlformats.org/officeDocument/2006/relationships">
+  <p:cSld>
+    <p:bg>
+      <p:bgPr>
+        <a:solidFill>
+          <a:srgbClr val="F4F7F9"/>
+        </a:solidFill>
+      </p:bgPr>
+    </p:bg>
+    <p:spTree>
+      <p:nvGrpSpPr>
+        <p:cNvPr id="1" name=""/>
+        <p:cNvGrpSpPr/>
+        <p:nvPr/>
+      </p:nvGrpSpPr>
+      <p:grpSpPr/>
+      <p:sp>
+        <p:nvSpPr>
+          <p:cNvPr id="2" name="Text 0"/>
+          <p:cNvSpPr txBox="1"/>
+          <p:nvPr/>
+        </p:nvSpPr>
+        <p:spPr>
+          <a:xfrm>
+            <a:off x="548640" y="457200"/>
+            <a:ext cx="9144000" cy="365760"/>
+          </a:xfrm>
+          <a:prstGeom prst="rect">
+            <a:avLst/>
+          </a:prstGeom>
+          <a:noFill/>
+          <a:ln/>
+        </p:spPr>
+        <p:txBody>
+          <a:bodyPr wrap="square" lIns="0" tIns="0" rIns="0" bIns="0" rtlCol="0" anchor="ctr"/>
+          <a:lstStyle/>
+          <a:p>
+            <a:pPr indent="0" marL="0">
+              <a:buNone/>
+            </a:pPr>
+            <a:r>
+              <a:rPr lang="en-US" sz="1300" b="1" spc="200" kern="0" dirty="0">
+                <a:solidFill>
+                  <a:srgbClr val="F2A541"/>
+                </a:solidFill>
+                <a:latin typeface="Calibri" pitchFamily="34" charset="0"/>
+                <a:ea typeface="Calibri" pitchFamily="34" charset="-122"/>
+                <a:cs typeface="Calibri" pitchFamily="34" charset="-120"/>
+              </a:rPr>
+              <a:t>RAID 5 · LA PARITAT</a:t>
+            </a:r>
+            <a:endParaRPr lang="en-US" sz="1300" dirty="0"/>
+          </a:p>
+        </p:txBody>
+      </p:sp>
+      <p:sp>
+        <p:nvSpPr>
+          <p:cNvPr id="3" name="Text 1"/>
+          <p:cNvSpPr txBox="1"/>
+          <p:nvPr/>
+        </p:nvSpPr>
+        <p:spPr>
+          <a:xfrm>
+            <a:off x="548640" y="822960"/>
+            <a:ext cx="10789920" cy="640080"/>
+          </a:xfrm>
+          <a:prstGeom prst="rect">
+            <a:avLst/>
+          </a:prstGeom>
+          <a:noFill/>
+          <a:ln/>
+        </p:spPr>
+        <p:txBody>
+          <a:bodyPr wrap="square" lIns="0" tIns="0" rIns="0" bIns="0" rtlCol="0" anchor="ctr"/>
+          <a:lstStyle/>
+          <a:p>
+            <a:pPr indent="0" marL="0">
+              <a:buNone/>
+            </a:pPr>
+            <a:r>
+              <a:rPr lang="en-US" sz="2800" b="1" dirty="0">
+                <a:solidFill>
+                  <a:srgbClr val="16242E"/>
+                </a:solidFill>
+                <a:latin typeface="Cambria" pitchFamily="34" charset="0"/>
+                <a:ea typeface="Cambria" pitchFamily="34" charset="-122"/>
+                <a:cs typeface="Cambria" pitchFamily="34" charset="-120"/>
+              </a:rPr>
+              <a:t>Com funciona la paritat?</a:t>
+            </a:r>
+            <a:endParaRPr lang="en-US" sz="2800" dirty="0"/>
+          </a:p>
+        </p:txBody>
+      </p:sp>
+      <p:sp>
+        <p:nvSpPr>
+          <p:cNvPr id="4" name="Text 2"/>
+          <p:cNvSpPr txBox="1"/>
+          <p:nvPr/>
+        </p:nvSpPr>
+        <p:spPr>
+          <a:xfrm>
+            <a:off x="11551615" y="6446520"/>
+            <a:ext cx="457200" cy="274320"/>
+          </a:xfrm>
+          <a:prstGeom prst="rect">
+            <a:avLst/>
+          </a:prstGeom>
+          <a:noFill/>
+          <a:ln/>
+        </p:spPr>
+        <p:txBody>
+          <a:bodyPr wrap="square" lIns="0" tIns="0" rIns="0" bIns="0" rtlCol="0" anchor="ctr"/>
+          <a:lstStyle/>
+          <a:p>
+            <a:pPr algn="r" indent="0" marL="0">
+              <a:buNone/>
+            </a:pPr>
+            <a:r>
+              <a:rPr lang="en-US" sz="1100" dirty="0">
+                <a:solidFill>
+                  <a:srgbClr val="5B6B77"/>
+                </a:solidFill>
+                <a:latin typeface="Calibri" pitchFamily="34" charset="0"/>
+                <a:ea typeface="Calibri" pitchFamily="34" charset="-122"/>
+                <a:cs typeface="Calibri" pitchFamily="34" charset="-120"/>
+              </a:rPr>
+              <a:t>16</a:t>
+            </a:r>
+            <a:endParaRPr lang="en-US" sz="1100" dirty="0"/>
+          </a:p>
+        </p:txBody>
+      </p:sp>
+      <p:sp>
+        <p:nvSpPr>
+          <p:cNvPr id="5" name="Shape 3"/>
+          <p:cNvSpPr/>
+          <p:nvPr/>
+        </p:nvSpPr>
+        <p:spPr>
+          <a:xfrm>
+            <a:off x="655168" y="1661160"/>
+            <a:ext cx="5212080" cy="4279392"/>
+          </a:xfrm>
+          <a:prstGeom prst="roundRect">
+            <a:avLst>
+              <a:gd name="adj" fmla="val 2791"/>
+            </a:avLst>
+          </a:prstGeom>
+          <a:solidFill>
+            <a:srgbClr val="FFFFFF"/>
+          </a:solidFill>
+          <a:ln w="12700">
+            <a:solidFill>
+              <a:srgbClr val="E2E8ED"/>
+            </a:solidFill>
+            <a:prstDash val="solid"/>
+          </a:ln>
+          <a:effectLst>
+            <a:outerShdw sx="100000" sy="100000" kx="0" ky="0" algn="bl" rotWithShape="0" blurRad="101600" dist="38100" dir="5400000">
+              <a:srgbClr val="16242E">
+                <a:alpha val="12000"/>
+              </a:srgbClr>
+            </a:outerShdw>
+          </a:effectLst>
+        </p:spPr>
+        <p:txBody>
+          <a:bodyPr/>
+          <a:p/>
+        </p:txBody>
+      </p:sp>
+      <p:sp>
+        <p:nvSpPr>
+          <p:cNvPr id="6" name="Shape 4"/>
+          <p:cNvSpPr/>
+          <p:nvPr/>
+        </p:nvSpPr>
+        <p:spPr>
+          <a:xfrm>
+            <a:off x="1039216" y="2045208"/>
+            <a:ext cx="731520" cy="731520"/>
+          </a:xfrm>
+          <a:prstGeom prst="ellipse">
+            <a:avLst/>
+          </a:prstGeom>
+          <a:solidFill>
+            <a:srgbClr val="0B1B29"/>
+          </a:solidFill>
+          <a:ln/>
+        </p:spPr>
+        <p:txBody>
+          <a:bodyPr/>
+          <a:p/>
+        </p:txBody>
+      </p:sp>
+      <p:pic>
+        <p:nvPicPr>
+          <p:cNvPr id="7" name="Image 0" descr="/tmp/claude-0/-home-user-SMX-0226-Seguretat-Informatica/a92ac1fc-9241-54c9-9c87-68470d7a571f/scratchpad/aa2/icon_heartbeat.png">    </p:cNvPr>
+          <p:cNvPicPr>
+            <a:picLocks noChangeAspect="1"/>
+          </p:cNvPicPr>
+          <p:nvPr/>
+        </p:nvPicPr>
+        <p:blipFill>
+          <a:blip r:embed="rId4"/>
+          <a:stretch>
+            <a:fillRect/>
+          </a:stretch>
+        </p:blipFill>
+        <p:spPr>
+          <a:xfrm>
+            <a:off x="1203808" y="2209800"/>
+            <a:ext cx="402336" cy="402336"/>
+          </a:xfrm>
+          <a:prstGeom prst="rect">
+            <a:avLst/>
+          </a:prstGeom>
+        </p:spPr>
+      </p:pic>
+      <p:sp>
+        <p:nvSpPr>
+          <p:cNvPr id="8" name="Text 5"/>
+          <p:cNvSpPr txBox="1"/>
+          <p:nvPr/>
+        </p:nvSpPr>
+        <p:spPr>
+          <a:xfrm>
+            <a:off x="1999336" y="2243328"/>
+            <a:ext cx="3483864" cy="335280"/>
+          </a:xfrm>
+          <a:prstGeom prst="rect">
+            <a:avLst/>
+          </a:prstGeom>
+          <a:noFill/>
+          <a:ln/>
+        </p:spPr>
+        <p:txBody>
+          <a:bodyPr wrap="square" lIns="0" tIns="0" rIns="0" bIns="0" rtlCol="0" anchor="ctr"/>
+          <a:lstStyle/>
+          <a:p>
+            <a:pPr indent="0" marL="0">
+              <a:buNone/>
+            </a:pPr>
+            <a:r>
+              <a:rPr lang="en-US" sz="2200" b="1" dirty="0">
+                <a:solidFill>
+                  <a:srgbClr val="16242E"/>
+                </a:solidFill>
+                <a:latin typeface="Cambria" pitchFamily="34" charset="0"/>
+                <a:ea typeface="Cambria" pitchFamily="34" charset="-122"/>
+                <a:cs typeface="Cambria" pitchFamily="34" charset="-120"/>
+              </a:rPr>
+              <a:t>Analogia amb sumes</a:t>
+            </a:r>
+            <a:endParaRPr lang="en-US" sz="2200" dirty="0"/>
+          </a:p>
+        </p:txBody>
+      </p:sp>
+      <p:sp>
+        <p:nvSpPr>
+          <p:cNvPr id="9" name="Text 6"/>
+          <p:cNvSpPr txBox="1"/>
+          <p:nvPr/>
+        </p:nvSpPr>
+        <p:spPr>
+          <a:xfrm>
+            <a:off x="1039216" y="3069336"/>
+            <a:ext cx="4443984" cy="2176272"/>
+          </a:xfrm>
+          <a:prstGeom prst="rect">
+            <a:avLst/>
+          </a:prstGeom>
+          <a:noFill/>
+          <a:ln/>
+        </p:spPr>
+        <p:txBody>
+          <a:bodyPr wrap="square" lIns="0" tIns="0" rIns="0" bIns="0" rtlCol="0" anchor="t"/>
+          <a:lstStyle/>
+          <a:p>
+            <a:pPr indent="0" marL="0">
+              <a:lnSpc>
+                <a:spcPts val="2448"/>
+              </a:lnSpc>
+              <a:buNone/>
+            </a:pPr>
+            <a:r>
+              <a:rPr lang="en-US" sz="1800" dirty="0" b="0">
+                <a:solidFill>
+                  <a:srgbClr val="5B6B77"/>
+                </a:solidFill>
+                <a:latin typeface="Calibri" pitchFamily="34" charset="0"/>
+                <a:ea typeface="Calibri" pitchFamily="34" charset="-122"/>
+                <a:cs typeface="Calibri" pitchFamily="34" charset="-120"/>
+              </a:rPr>
+              <a:t>Caixa A = 3, caixa B = 5 i, a la caixa C, la paritat: 3 + 5 = 8.</a:t>
+            </a:r>
+            <a:endParaRPr lang="en-US" sz="1800" dirty="0"/>
+          </a:p>
+          <a:p>
+            <a:pPr indent="0" marL="0">
+              <a:lnSpc>
+                <a:spcPts val="2448"/>
+              </a:lnSpc>
+              <a:buNone/>
+            </a:pPr>
+            <a:r>
+              <a:rPr lang="en-US" sz="1800" dirty="0" b="0">
+                <a:solidFill>
+                  <a:srgbClr val="5B6B77"/>
+                </a:solidFill>
+                <a:latin typeface="Calibri" pitchFamily="34" charset="0"/>
+                <a:ea typeface="Calibri" pitchFamily="34" charset="-122"/>
+                <a:cs typeface="Calibri" pitchFamily="34" charset="-120"/>
+              </a:rPr>
+              <a:t>Es perd A → 8 − 5 = 3</a:t>
+            </a:r>
+            <a:endParaRPr lang="en-US" sz="1800" dirty="0"/>
+          </a:p>
+          <a:p>
+            <a:pPr indent="0" marL="0">
+              <a:lnSpc>
+                <a:spcPts val="2448"/>
+              </a:lnSpc>
+              <a:buNone/>
+            </a:pPr>
+            <a:r>
+              <a:rPr lang="en-US" sz="1800" dirty="0" b="0">
+                <a:solidFill>
+                  <a:srgbClr val="5B6B77"/>
+                </a:solidFill>
+                <a:latin typeface="Calibri" pitchFamily="34" charset="0"/>
+                <a:ea typeface="Calibri" pitchFamily="34" charset="-122"/>
+                <a:cs typeface="Calibri" pitchFamily="34" charset="-120"/>
+              </a:rPr>
+              <a:t>Es perd B → 8 − 3 = 5</a:t>
+            </a:r>
+            <a:endParaRPr lang="en-US" sz="1800" dirty="0"/>
+          </a:p>
+          <a:p>
+            <a:pPr indent="0" marL="0">
+              <a:lnSpc>
+                <a:spcPts val="2448"/>
+              </a:lnSpc>
+              <a:buNone/>
+            </a:pPr>
+            <a:r>
+              <a:rPr lang="en-US" sz="1800" dirty="0" b="0">
+                <a:solidFill>
+                  <a:srgbClr val="5B6B77"/>
+                </a:solidFill>
+                <a:latin typeface="Calibri" pitchFamily="34" charset="0"/>
+                <a:ea typeface="Calibri" pitchFamily="34" charset="-122"/>
+                <a:cs typeface="Calibri" pitchFamily="34" charset="-120"/>
+              </a:rPr>
+              <a:t>Es perd C → 3 + 5 = 8</a:t>
+            </a:r>
+            <a:endParaRPr lang="en-US" sz="1800" dirty="0"/>
+          </a:p>
+          <a:p>
+            <a:pPr indent="0" marL="0">
+              <a:lnSpc>
+                <a:spcPts val="2448"/>
+              </a:lnSpc>
+              <a:buNone/>
+            </a:pPr>
+            <a:r>
+              <a:rPr lang="en-US" sz="1800" dirty="0" b="1">
+                <a:solidFill>
+                  <a:srgbClr val="5B6B77"/>
+                </a:solidFill>
+                <a:latin typeface="Calibri" pitchFamily="34" charset="0"/>
+                <a:ea typeface="Calibri" pitchFamily="34" charset="-122"/>
+                <a:cs typeface="Calibri" pitchFamily="34" charset="-120"/>
+              </a:rPr>
+              <a:t>Es perden dues caixes → impossible: el RAID 5 només suporta 1 fallada.</a:t>
+            </a:r>
+            <a:endParaRPr lang="en-US" sz="1800" dirty="0"/>
+          </a:p>
+        </p:txBody>
+      </p:sp>
+      <p:sp>
+        <p:nvSpPr>
+          <p:cNvPr id="10" name="Shape 7"/>
+          <p:cNvSpPr/>
+          <p:nvPr/>
+        </p:nvSpPr>
+        <p:spPr>
+          <a:xfrm>
+            <a:off x="6324448" y="1661160"/>
+            <a:ext cx="5212080" cy="4279392"/>
+          </a:xfrm>
+          <a:prstGeom prst="roundRect">
+            <a:avLst>
+              <a:gd name="adj" fmla="val 2791"/>
+            </a:avLst>
+          </a:prstGeom>
+          <a:solidFill>
+            <a:srgbClr val="FFFFFF"/>
+          </a:solidFill>
+          <a:ln w="12700">
+            <a:solidFill>
+              <a:srgbClr val="E2E8ED"/>
+            </a:solidFill>
+            <a:prstDash val="solid"/>
+          </a:ln>
+          <a:effectLst>
+            <a:outerShdw sx="100000" sy="100000" kx="0" ky="0" algn="bl" rotWithShape="0" blurRad="101600" dist="38100" dir="5400000">
+              <a:srgbClr val="16242E">
+                <a:alpha val="12000"/>
+              </a:srgbClr>
+            </a:outerShdw>
+          </a:effectLst>
+        </p:spPr>
+        <p:txBody>
+          <a:bodyPr/>
+          <a:p/>
+        </p:txBody>
+      </p:sp>
+      <p:sp>
+        <p:nvSpPr>
+          <p:cNvPr id="11" name="Shape 8"/>
+          <p:cNvSpPr/>
+          <p:nvPr/>
+        </p:nvSpPr>
+        <p:spPr>
+          <a:xfrm>
+            <a:off x="6708496" y="2045208"/>
+            <a:ext cx="731520" cy="731520"/>
+          </a:xfrm>
+          <a:prstGeom prst="ellipse">
+            <a:avLst/>
+          </a:prstGeom>
+          <a:solidFill>
+            <a:srgbClr val="0B1B29"/>
+          </a:solidFill>
+          <a:ln/>
+        </p:spPr>
+        <p:txBody>
+          <a:bodyPr/>
+          <a:p/>
+        </p:txBody>
+      </p:sp>
+      <p:pic>
+        <p:nvPicPr>
+          <p:cNvPr id="12" name="Image 1" descr="/tmp/claude-0/-home-user-SMX-0226-Seguretat-Informatica/a92ac1fc-9241-54c9-9c87-68470d7a571f/scratchpad/aa2/icon_terminal.png">    </p:cNvPr>
+          <p:cNvPicPr>
+            <a:picLocks noChangeAspect="1"/>
+          </p:cNvPicPr>
+          <p:nvPr/>
+        </p:nvPicPr>
+        <p:blipFill>
+          <a:blip r:embed="rId3"/>
+          <a:stretch>
+            <a:fillRect/>
+          </a:stretch>
+        </p:blipFill>
+        <p:spPr>
+          <a:xfrm>
+            <a:off x="6873087" y="2209800"/>
+            <a:ext cx="402336" cy="402336"/>
+          </a:xfrm>
+          <a:prstGeom prst="rect">
+            <a:avLst/>
+          </a:prstGeom>
+        </p:spPr>
+      </p:pic>
+      <p:sp>
+        <p:nvSpPr>
+          <p:cNvPr id="13" name="Text 9"/>
+          <p:cNvSpPr txBox="1"/>
+          <p:nvPr/>
+        </p:nvSpPr>
+        <p:spPr>
+          <a:xfrm>
+            <a:off x="7668616" y="2243328"/>
+            <a:ext cx="3483864" cy="335280"/>
+          </a:xfrm>
+          <a:prstGeom prst="rect">
+            <a:avLst/>
+          </a:prstGeom>
+          <a:noFill/>
+          <a:ln/>
+        </p:spPr>
+        <p:txBody>
+          <a:bodyPr wrap="square" lIns="0" tIns="0" rIns="0" bIns="0" rtlCol="0" anchor="ctr"/>
+          <a:lstStyle/>
+          <a:p>
+            <a:pPr indent="0" marL="0">
+              <a:buNone/>
+            </a:pPr>
+            <a:r>
+              <a:rPr lang="en-US" sz="2200" b="1" dirty="0">
+                <a:solidFill>
+                  <a:srgbClr val="16242E"/>
+                </a:solidFill>
+                <a:latin typeface="Cambria" pitchFamily="34" charset="0"/>
+                <a:ea typeface="Cambria" pitchFamily="34" charset="-122"/>
+                <a:cs typeface="Cambria" pitchFamily="34" charset="-120"/>
+              </a:rPr>
+              <a:t>Amb bits: l'operació XOR</a:t>
+            </a:r>
+            <a:endParaRPr lang="en-US" sz="2200" dirty="0"/>
+          </a:p>
+        </p:txBody>
+      </p:sp>
+      <p:sp>
+        <p:nvSpPr>
+          <p:cNvPr id="14" name="Text 10"/>
+          <p:cNvSpPr txBox="1"/>
+          <p:nvPr/>
+        </p:nvSpPr>
+        <p:spPr>
+          <a:xfrm>
+            <a:off x="6708496" y="3069336"/>
+            <a:ext cx="4443984" cy="2487168"/>
+          </a:xfrm>
+          <a:prstGeom prst="rect">
+            <a:avLst/>
+          </a:prstGeom>
+          <a:noFill/>
+          <a:ln/>
+        </p:spPr>
+        <p:txBody>
+          <a:bodyPr wrap="square" lIns="0" tIns="0" rIns="0" bIns="0" rtlCol="0" anchor="t"/>
+          <a:lstStyle/>
+          <a:p>
+            <a:pPr indent="0" marL="0">
+              <a:lnSpc>
+                <a:spcPts val="2448"/>
+              </a:lnSpc>
+              <a:buNone/>
+            </a:pPr>
+            <a:r>
+              <a:rPr lang="en-US" sz="1800" dirty="0" b="0">
+                <a:solidFill>
+                  <a:srgbClr val="5B6B77"/>
+                </a:solidFill>
+                <a:ea typeface="Calibri" pitchFamily="34" charset="-122"/>
+                <a:latin typeface="Consolas"/>
+              </a:rPr>
+              <a:t>Disc 1:   1 0 1 1</a:t>
+            </a:r>
+            <a:endParaRPr lang="en-US" sz="1800" dirty="0"/>
+          </a:p>
+          <a:p>
+            <a:pPr indent="0" marL="0">
+              <a:lnSpc>
+                <a:spcPts val="2448"/>
+              </a:lnSpc>
+              <a:buNone/>
+            </a:pPr>
+            <a:r>
+              <a:rPr lang="en-US" sz="1800" dirty="0" b="0">
+                <a:solidFill>
+                  <a:srgbClr val="5B6B77"/>
+                </a:solidFill>
+                <a:ea typeface="Calibri" pitchFamily="34" charset="-122"/>
+                <a:latin typeface="Consolas"/>
+              </a:rPr>
+              <a:t>Disc 2:   0 1 1 0</a:t>
+            </a:r>
+            <a:endParaRPr lang="en-US" sz="1800" dirty="0"/>
+          </a:p>
+          <a:p>
+            <a:pPr indent="0" marL="0">
+              <a:lnSpc>
+                <a:spcPts val="2448"/>
+              </a:lnSpc>
+              <a:buNone/>
+            </a:pPr>
+            <a:r>
+              <a:rPr lang="en-US" sz="1800" dirty="0" b="1">
+                <a:solidFill>
+                  <a:srgbClr val="5B6B77"/>
+                </a:solidFill>
+                <a:ea typeface="Calibri" pitchFamily="34" charset="-122"/>
+                <a:latin typeface="Consolas"/>
+              </a:rPr>
+              <a:t>Paritat:  1 1 0 1</a:t>
+            </a:r>
+            <a:endParaRPr lang="en-US" sz="1800" dirty="0"/>
+          </a:p>
+          <a:p>
+            <a:pPr indent="0" marL="0">
+              <a:lnSpc>
+                <a:spcPts val="2448"/>
+              </a:lnSpc>
+              <a:buNone/>
+            </a:pPr>
+            <a:r>
+              <a:rPr lang="en-US" sz="1800" dirty="0" b="0">
+                <a:solidFill>
+                  <a:srgbClr val="5B6B77"/>
+                </a:solidFill>
+                <a:latin typeface="Calibri" pitchFamily="34" charset="0"/>
+                <a:ea typeface="Calibri" pitchFamily="34" charset="-122"/>
+                <a:cs typeface="Calibri" pitchFamily="34" charset="-120"/>
+              </a:rPr>
+              <a:t>XOR: 1 si els bits són diferents, 0 si són iguals.</a:t>
+            </a:r>
+            <a:endParaRPr lang="en-US" sz="1800" dirty="0"/>
+          </a:p>
+          <a:p>
+            <a:pPr indent="0" marL="0">
+              <a:lnSpc>
+                <a:spcPts val="2448"/>
+              </a:lnSpc>
+              <a:buNone/>
+            </a:pPr>
+            <a:r>
+              <a:rPr lang="en-US" sz="1800" dirty="0" b="1">
+                <a:solidFill>
+                  <a:srgbClr val="5B6B77"/>
+                </a:solidFill>
+                <a:latin typeface="Calibri" pitchFamily="34" charset="0"/>
+                <a:ea typeface="Calibri" pitchFamily="34" charset="-122"/>
+                <a:cs typeface="Calibri" pitchFamily="34" charset="-120"/>
+              </a:rPr>
+              <a:t>Si falla el disc 1: disc 2 XOR paritat = 1 0 1 1 → recuperat.</a:t>
+            </a:r>
+            <a:endParaRPr lang="en-US" sz="1800" dirty="0"/>
+          </a:p>
+        </p:txBody>
+      </p:sp>
+    </p:spTree>
+  </p:cSld>
+  <p:clrMapOvr>
+    <a:masterClrMapping/>
+  </p:clrMapOvr>
+</p:sld>
+</file>
+
+<file path=ppt/slides/slide17.xml><?xml version="1.0" encoding="utf-8"?>
 <p:sld xmlns:a="http://schemas.openxmlformats.org/drawingml/2006/main" xmlns:r="http://schemas.openxmlformats.org/officeDocument/2006/relationships" xmlns:p="http://schemas.openxmlformats.org/presentationml/2006/main">
   <p:cSld name="Slide 9">
     <p:bg>
@@ -5257,7 +5890,7 @@
 </p:sld>
 </file>
 
-<file path=ppt/slides/slide17.xml><?xml version="1.0" encoding="utf-8"?>
+<file path=ppt/slides/slide18.xml><?xml version="1.0" encoding="utf-8"?>
 <p:sld xmlns:a="http://schemas.openxmlformats.org/drawingml/2006/main" xmlns:p="http://schemas.openxmlformats.org/presentationml/2006/main" xmlns:r="http://schemas.openxmlformats.org/officeDocument/2006/relationships">
   <p:cSld>
     <p:bg>
@@ -5446,7 +6079,7 @@
 </p:sld>
 </file>
 
-<file path=ppt/slides/slide18.xml><?xml version="1.0" encoding="utf-8"?>
+<file path=ppt/slides/slide19.xml><?xml version="1.0" encoding="utf-8"?>
 <p:sld xmlns:a="http://schemas.openxmlformats.org/drawingml/2006/main" xmlns:r="http://schemas.openxmlformats.org/officeDocument/2006/relationships" xmlns:p="http://schemas.openxmlformats.org/presentationml/2006/main">
   <p:cSld name="Slide 10">
     <p:bg>
@@ -8561,249 +9194,6 @@
 </p:sld>
 </file>
 
-<file path=ppt/slides/slide19.xml><?xml version="1.0" encoding="utf-8"?>
-<p:sld xmlns:a="http://schemas.openxmlformats.org/drawingml/2006/main" xmlns:r="http://schemas.openxmlformats.org/officeDocument/2006/relationships" xmlns:p="http://schemas.openxmlformats.org/presentationml/2006/main">
-  <p:cSld name="Slide 11">
-    <p:bg>
-      <p:bgPr>
-        <a:solidFill>
-          <a:srgbClr val="F4F7F9"/>
-        </a:solidFill>
-      </p:bgPr>
-    </p:bg>
-    <p:spTree>
-      <p:nvGrpSpPr>
-        <p:cNvPr id="1" name=""/>
-        <p:cNvGrpSpPr/>
-        <p:nvPr/>
-      </p:nvGrpSpPr>
-      <p:grpSpPr>
-        <a:xfrm>
-          <a:off x="0" y="0"/>
-          <a:ext cx="0" cy="0"/>
-          <a:chOff x="0" y="0"/>
-          <a:chExt cx="0" cy="0"/>
-        </a:xfrm>
-      </p:grpSpPr>
-      <p:sp>
-        <p:nvSpPr>
-          <p:cNvPr id="2" name="Text 0"/>
-          <p:cNvSpPr txBox="1"/>
-          <p:nvPr/>
-        </p:nvSpPr>
-        <p:spPr>
-          <a:xfrm>
-            <a:off x="548640" y="457200"/>
-            <a:ext cx="9144000" cy="365760"/>
-          </a:xfrm>
-          <a:prstGeom prst="rect">
-            <a:avLst/>
-          </a:prstGeom>
-          <a:noFill/>
-          <a:ln/>
-        </p:spPr>
-        <p:txBody>
-          <a:bodyPr wrap="square" lIns="0" tIns="0" rIns="0" bIns="0" rtlCol="0" anchor="ctr"/>
-          <a:lstStyle/>
-          <a:p>
-            <a:pPr indent="0" marL="0">
-              <a:buNone/>
-            </a:pPr>
-            <a:r>
-              <a:rPr lang="en-US" sz="1300" b="1" spc="200" kern="0" dirty="0">
-                <a:solidFill>
-                  <a:srgbClr val="F2A541"/>
-                </a:solidFill>
-                <a:latin typeface="Calibri" pitchFamily="34" charset="0"/>
-                <a:ea typeface="Calibri" pitchFamily="34" charset="-122"/>
-                <a:cs typeface="Calibri" pitchFamily="34" charset="-120"/>
-              </a:rPr>
-              <a:t>CENTRALITZAR L'EMMAGATZEMATGE</a:t>
-            </a:r>
-            <a:endParaRPr lang="en-US" sz="1300" dirty="0"/>
-          </a:p>
-        </p:txBody>
-      </p:sp>
-      <p:sp>
-        <p:nvSpPr>
-          <p:cNvPr id="3" name="Text 1"/>
-          <p:cNvSpPr txBox="1"/>
-          <p:nvPr/>
-        </p:nvSpPr>
-        <p:spPr>
-          <a:xfrm>
-            <a:off x="548640" y="822960"/>
-            <a:ext cx="10789920" cy="640080"/>
-          </a:xfrm>
-          <a:prstGeom prst="rect">
-            <a:avLst/>
-          </a:prstGeom>
-          <a:noFill/>
-          <a:ln/>
-        </p:spPr>
-        <p:txBody>
-          <a:bodyPr wrap="square" lIns="0" tIns="0" rIns="0" bIns="0" rtlCol="0" anchor="ctr"/>
-          <a:lstStyle/>
-          <a:p>
-            <a:pPr indent="0" marL="0">
-              <a:buNone/>
-            </a:pPr>
-            <a:r>
-              <a:rPr lang="en-US" sz="2800" b="1" dirty="0">
-                <a:solidFill>
-                  <a:srgbClr val="16242E"/>
-                </a:solidFill>
-                <a:latin typeface="Cambria" pitchFamily="34" charset="0"/>
-                <a:ea typeface="Cambria" pitchFamily="34" charset="-122"/>
-                <a:cs typeface="Cambria" pitchFamily="34" charset="-120"/>
-              </a:rPr>
-              <a:t>Per què les dades no haurien d'estar a les estacions de treball</a:t>
-            </a:r>
-            <a:endParaRPr lang="en-US" sz="2800" dirty="0"/>
-          </a:p>
-        </p:txBody>
-      </p:sp>
-      <p:sp>
-        <p:nvSpPr>
-          <p:cNvPr id="4" name="Text 2"/>
-          <p:cNvSpPr txBox="1"/>
-          <p:nvPr/>
-        </p:nvSpPr>
-        <p:spPr>
-          <a:xfrm>
-            <a:off x="11551615" y="6446520"/>
-            <a:ext cx="457200" cy="274320"/>
-          </a:xfrm>
-          <a:prstGeom prst="rect">
-            <a:avLst/>
-          </a:prstGeom>
-          <a:noFill/>
-          <a:ln/>
-        </p:spPr>
-        <p:txBody>
-          <a:bodyPr wrap="square" lIns="0" tIns="0" rIns="0" bIns="0" rtlCol="0" anchor="ctr"/>
-          <a:lstStyle/>
-          <a:p>
-            <a:pPr algn="r" indent="0" marL="0">
-              <a:buNone/>
-            </a:pPr>
-            <a:r>
-              <a:rPr lang="en-US" sz="1100" dirty="0">
-                <a:solidFill>
-                  <a:srgbClr val="5B6B77"/>
-                </a:solidFill>
-                <a:latin typeface="Calibri" pitchFamily="34" charset="0"/>
-                <a:ea typeface="Calibri" pitchFamily="34" charset="-122"/>
-                <a:cs typeface="Calibri" pitchFamily="34" charset="-120"/>
-              </a:rPr>
-              <a:t>20</a:t>
-            </a:r>
-            <a:endParaRPr lang="en-US" sz="1100" dirty="0"/>
-          </a:p>
-        </p:txBody>
-      </p:sp>
-      <p:sp>
-        <p:nvSpPr>
-          <p:cNvPr id="5" name="Text 3"/>
-          <p:cNvSpPr txBox="1"/>
-          <p:nvPr/>
-        </p:nvSpPr>
-        <p:spPr>
-          <a:xfrm>
-            <a:off x="640080" y="1661160"/>
-            <a:ext cx="10789920" cy="2574417"/>
-          </a:xfrm>
-          <a:prstGeom prst="rect">
-            <a:avLst/>
-          </a:prstGeom>
-          <a:noFill/>
-          <a:ln/>
-        </p:spPr>
-        <p:txBody>
-          <a:bodyPr wrap="square" lIns="0" tIns="0" rIns="0" bIns="0" rtlCol="0" anchor="t"/>
-          <a:lstStyle/>
-          <a:p>
-            <a:pPr marL="342900" indent="-342900">
-              <a:lnSpc>
-                <a:spcPts val="2508"/>
-              </a:lnSpc>
-              <a:spcAft>
-                <a:spcPts val="1741"/>
-              </a:spcAft>
-              <a:buSzPct val="100000"/>
-              <a:buChar char="▪"/>
-            </a:pPr>
-            <a:r>
-              <a:rPr lang="en-US" sz="1800" dirty="0">
-                <a:solidFill>
-                  <a:srgbClr val="16242E"/>
-                </a:solidFill>
-                <a:latin typeface="Calibri" pitchFamily="34" charset="0"/>
-                <a:ea typeface="Calibri" pitchFamily="34" charset="-122"/>
-                <a:cs typeface="Calibri" pitchFamily="34" charset="-120"/>
-              </a:rPr>
-              <a:t>Les dades centralitzades eviten la inconsistència de les dades: quan un mateix document existeix en diversos equips amb versions diferents.</a:t>
-            </a:r>
-            <a:endParaRPr lang="en-US" sz="1800" dirty="0"/>
-          </a:p>
-          <a:p>
-            <a:pPr marL="342900" indent="-342900">
-              <a:lnSpc>
-                <a:spcPts val="2508"/>
-              </a:lnSpc>
-              <a:spcAft>
-                <a:spcPts val="1741"/>
-              </a:spcAft>
-              <a:buSzPct val="100000"/>
-              <a:buChar char="▪"/>
-            </a:pPr>
-            <a:r>
-              <a:rPr lang="en-US" sz="1800" dirty="0">
-                <a:solidFill>
-                  <a:srgbClr val="16242E"/>
-                </a:solidFill>
-                <a:latin typeface="Calibri" pitchFamily="34" charset="0"/>
-                <a:ea typeface="Calibri" pitchFamily="34" charset="-122"/>
-                <a:cs typeface="Calibri" pitchFamily="34" charset="-120"/>
-              </a:rPr>
-              <a:t>A més, permeten fer còpies de seguretat de forma centralitzada i amb més facilitat, en lloc de dependre que cada usuari en faci al seu propi equip.</a:t>
-            </a:r>
-            <a:endParaRPr lang="en-US" sz="1800" dirty="0"/>
-          </a:p>
-          <a:p>
-            <a:pPr marL="342900" indent="-342900">
-              <a:lnSpc>
-                <a:spcPts val="2508"/>
-              </a:lnSpc>
-              <a:spcAft>
-                <a:spcPts val="1741"/>
-              </a:spcAft>
-              <a:buSzPct val="100000"/>
-              <a:buChar char="▪"/>
-            </a:pPr>
-            <a:r>
-              <a:rPr lang="en-US" sz="1800" dirty="0">
-                <a:solidFill>
-                  <a:srgbClr val="16242E"/>
-                </a:solidFill>
-                <a:latin typeface="Calibri" pitchFamily="34" charset="0"/>
-                <a:ea typeface="Calibri" pitchFamily="34" charset="-122"/>
-                <a:cs typeface="Calibri" pitchFamily="34" charset="-120"/>
-              </a:rPr>
-              <a:t>Tres sistemes principals: DAS, NAS i SAN. Internament, el dispositiu que fa de servidor d'arxius sol usar RAID per tenir alta disponibilitat.</a:t>
-            </a:r>
-            <a:endParaRPr lang="en-US" sz="1800" dirty="0"/>
-          </a:p>
-        </p:txBody>
-      </p:sp>
-    </p:spTree>
-  </p:cSld>
-  <p:clrMapOvr>
-    <a:masterClrMapping/>
-  </p:clrMapOvr>
-</p:sld>
-</file>
-
 <file path=ppt/slides/slide2.xml><?xml version="1.0" encoding="utf-8"?>
 <p:sld xmlns:a="http://schemas.openxmlformats.org/drawingml/2006/main" xmlns:r="http://schemas.openxmlformats.org/officeDocument/2006/relationships" xmlns:p="http://schemas.openxmlformats.org/presentationml/2006/main">
   <p:cSld name="Slide 2">
@@ -9623,6 +10013,249 @@
 
 <file path=ppt/slides/slide20.xml><?xml version="1.0" encoding="utf-8"?>
 <p:sld xmlns:a="http://schemas.openxmlformats.org/drawingml/2006/main" xmlns:r="http://schemas.openxmlformats.org/officeDocument/2006/relationships" xmlns:p="http://schemas.openxmlformats.org/presentationml/2006/main">
+  <p:cSld name="Slide 11">
+    <p:bg>
+      <p:bgPr>
+        <a:solidFill>
+          <a:srgbClr val="F4F7F9"/>
+        </a:solidFill>
+      </p:bgPr>
+    </p:bg>
+    <p:spTree>
+      <p:nvGrpSpPr>
+        <p:cNvPr id="1" name=""/>
+        <p:cNvGrpSpPr/>
+        <p:nvPr/>
+      </p:nvGrpSpPr>
+      <p:grpSpPr>
+        <a:xfrm>
+          <a:off x="0" y="0"/>
+          <a:ext cx="0" cy="0"/>
+          <a:chOff x="0" y="0"/>
+          <a:chExt cx="0" cy="0"/>
+        </a:xfrm>
+      </p:grpSpPr>
+      <p:sp>
+        <p:nvSpPr>
+          <p:cNvPr id="2" name="Text 0"/>
+          <p:cNvSpPr txBox="1"/>
+          <p:nvPr/>
+        </p:nvSpPr>
+        <p:spPr>
+          <a:xfrm>
+            <a:off x="548640" y="457200"/>
+            <a:ext cx="9144000" cy="365760"/>
+          </a:xfrm>
+          <a:prstGeom prst="rect">
+            <a:avLst/>
+          </a:prstGeom>
+          <a:noFill/>
+          <a:ln/>
+        </p:spPr>
+        <p:txBody>
+          <a:bodyPr wrap="square" lIns="0" tIns="0" rIns="0" bIns="0" rtlCol="0" anchor="ctr"/>
+          <a:lstStyle/>
+          <a:p>
+            <a:pPr indent="0" marL="0">
+              <a:buNone/>
+            </a:pPr>
+            <a:r>
+              <a:rPr lang="en-US" sz="1300" b="1" spc="200" kern="0" dirty="0">
+                <a:solidFill>
+                  <a:srgbClr val="F2A541"/>
+                </a:solidFill>
+                <a:latin typeface="Calibri" pitchFamily="34" charset="0"/>
+                <a:ea typeface="Calibri" pitchFamily="34" charset="-122"/>
+                <a:cs typeface="Calibri" pitchFamily="34" charset="-120"/>
+              </a:rPr>
+              <a:t>CENTRALITZAR L'EMMAGATZEMATGE</a:t>
+            </a:r>
+            <a:endParaRPr lang="en-US" sz="1300" dirty="0"/>
+          </a:p>
+        </p:txBody>
+      </p:sp>
+      <p:sp>
+        <p:nvSpPr>
+          <p:cNvPr id="3" name="Text 1"/>
+          <p:cNvSpPr txBox="1"/>
+          <p:nvPr/>
+        </p:nvSpPr>
+        <p:spPr>
+          <a:xfrm>
+            <a:off x="548640" y="822960"/>
+            <a:ext cx="10789920" cy="640080"/>
+          </a:xfrm>
+          <a:prstGeom prst="rect">
+            <a:avLst/>
+          </a:prstGeom>
+          <a:noFill/>
+          <a:ln/>
+        </p:spPr>
+        <p:txBody>
+          <a:bodyPr wrap="square" lIns="0" tIns="0" rIns="0" bIns="0" rtlCol="0" anchor="ctr"/>
+          <a:lstStyle/>
+          <a:p>
+            <a:pPr indent="0" marL="0">
+              <a:buNone/>
+            </a:pPr>
+            <a:r>
+              <a:rPr lang="en-US" sz="2800" b="1" dirty="0">
+                <a:solidFill>
+                  <a:srgbClr val="16242E"/>
+                </a:solidFill>
+                <a:latin typeface="Cambria" pitchFamily="34" charset="0"/>
+                <a:ea typeface="Cambria" pitchFamily="34" charset="-122"/>
+                <a:cs typeface="Cambria" pitchFamily="34" charset="-120"/>
+              </a:rPr>
+              <a:t>Per què les dades no haurien d'estar a les estacions de treball</a:t>
+            </a:r>
+            <a:endParaRPr lang="en-US" sz="2800" dirty="0"/>
+          </a:p>
+        </p:txBody>
+      </p:sp>
+      <p:sp>
+        <p:nvSpPr>
+          <p:cNvPr id="4" name="Text 2"/>
+          <p:cNvSpPr txBox="1"/>
+          <p:nvPr/>
+        </p:nvSpPr>
+        <p:spPr>
+          <a:xfrm>
+            <a:off x="11551615" y="6446520"/>
+            <a:ext cx="457200" cy="274320"/>
+          </a:xfrm>
+          <a:prstGeom prst="rect">
+            <a:avLst/>
+          </a:prstGeom>
+          <a:noFill/>
+          <a:ln/>
+        </p:spPr>
+        <p:txBody>
+          <a:bodyPr wrap="square" lIns="0" tIns="0" rIns="0" bIns="0" rtlCol="0" anchor="ctr"/>
+          <a:lstStyle/>
+          <a:p>
+            <a:pPr algn="r" indent="0" marL="0">
+              <a:buNone/>
+            </a:pPr>
+            <a:r>
+              <a:rPr lang="en-US" sz="1100" dirty="0">
+                <a:solidFill>
+                  <a:srgbClr val="5B6B77"/>
+                </a:solidFill>
+                <a:latin typeface="Calibri" pitchFamily="34" charset="0"/>
+                <a:ea typeface="Calibri" pitchFamily="34" charset="-122"/>
+                <a:cs typeface="Calibri" pitchFamily="34" charset="-120"/>
+              </a:rPr>
+              <a:t>20</a:t>
+            </a:r>
+            <a:endParaRPr lang="en-US" sz="1100" dirty="0"/>
+          </a:p>
+        </p:txBody>
+      </p:sp>
+      <p:sp>
+        <p:nvSpPr>
+          <p:cNvPr id="5" name="Text 3"/>
+          <p:cNvSpPr txBox="1"/>
+          <p:nvPr/>
+        </p:nvSpPr>
+        <p:spPr>
+          <a:xfrm>
+            <a:off x="640080" y="1661160"/>
+            <a:ext cx="10789920" cy="2574417"/>
+          </a:xfrm>
+          <a:prstGeom prst="rect">
+            <a:avLst/>
+          </a:prstGeom>
+          <a:noFill/>
+          <a:ln/>
+        </p:spPr>
+        <p:txBody>
+          <a:bodyPr wrap="square" lIns="0" tIns="0" rIns="0" bIns="0" rtlCol="0" anchor="t"/>
+          <a:lstStyle/>
+          <a:p>
+            <a:pPr marL="342900" indent="-342900">
+              <a:lnSpc>
+                <a:spcPts val="2508"/>
+              </a:lnSpc>
+              <a:spcAft>
+                <a:spcPts val="1741"/>
+              </a:spcAft>
+              <a:buSzPct val="100000"/>
+              <a:buChar char="▪"/>
+            </a:pPr>
+            <a:r>
+              <a:rPr lang="en-US" sz="1800" dirty="0">
+                <a:solidFill>
+                  <a:srgbClr val="16242E"/>
+                </a:solidFill>
+                <a:latin typeface="Calibri" pitchFamily="34" charset="0"/>
+                <a:ea typeface="Calibri" pitchFamily="34" charset="-122"/>
+                <a:cs typeface="Calibri" pitchFamily="34" charset="-120"/>
+              </a:rPr>
+              <a:t>Les dades centralitzades eviten la inconsistència de les dades: quan un mateix document existeix en diversos equips amb versions diferents.</a:t>
+            </a:r>
+            <a:endParaRPr lang="en-US" sz="1800" dirty="0"/>
+          </a:p>
+          <a:p>
+            <a:pPr marL="342900" indent="-342900">
+              <a:lnSpc>
+                <a:spcPts val="2508"/>
+              </a:lnSpc>
+              <a:spcAft>
+                <a:spcPts val="1741"/>
+              </a:spcAft>
+              <a:buSzPct val="100000"/>
+              <a:buChar char="▪"/>
+            </a:pPr>
+            <a:r>
+              <a:rPr lang="en-US" sz="1800" dirty="0">
+                <a:solidFill>
+                  <a:srgbClr val="16242E"/>
+                </a:solidFill>
+                <a:latin typeface="Calibri" pitchFamily="34" charset="0"/>
+                <a:ea typeface="Calibri" pitchFamily="34" charset="-122"/>
+                <a:cs typeface="Calibri" pitchFamily="34" charset="-120"/>
+              </a:rPr>
+              <a:t>A més, permeten fer còpies de seguretat de forma centralitzada i amb més facilitat, en lloc de dependre que cada usuari en faci al seu propi equip.</a:t>
+            </a:r>
+            <a:endParaRPr lang="en-US" sz="1800" dirty="0"/>
+          </a:p>
+          <a:p>
+            <a:pPr marL="342900" indent="-342900">
+              <a:lnSpc>
+                <a:spcPts val="2508"/>
+              </a:lnSpc>
+              <a:spcAft>
+                <a:spcPts val="1741"/>
+              </a:spcAft>
+              <a:buSzPct val="100000"/>
+              <a:buChar char="▪"/>
+            </a:pPr>
+            <a:r>
+              <a:rPr lang="en-US" sz="1800" dirty="0">
+                <a:solidFill>
+                  <a:srgbClr val="16242E"/>
+                </a:solidFill>
+                <a:latin typeface="Calibri" pitchFamily="34" charset="0"/>
+                <a:ea typeface="Calibri" pitchFamily="34" charset="-122"/>
+                <a:cs typeface="Calibri" pitchFamily="34" charset="-120"/>
+              </a:rPr>
+              <a:t>Tres sistemes principals: DAS, NAS i SAN. Internament, el dispositiu que fa de servidor d'arxius sol usar RAID per tenir alta disponibilitat.</a:t>
+            </a:r>
+            <a:endParaRPr lang="en-US" sz="1800" dirty="0"/>
+          </a:p>
+        </p:txBody>
+      </p:sp>
+    </p:spTree>
+  </p:cSld>
+  <p:clrMapOvr>
+    <a:masterClrMapping/>
+  </p:clrMapOvr>
+</p:sld>
+</file>
+
+<file path=ppt/slides/slide21.xml><?xml version="1.0" encoding="utf-8"?>
+<p:sld xmlns:a="http://schemas.openxmlformats.org/drawingml/2006/main" xmlns:r="http://schemas.openxmlformats.org/officeDocument/2006/relationships" xmlns:p="http://schemas.openxmlformats.org/presentationml/2006/main">
   <p:cSld name="Slide 12">
     <p:bg>
       <p:bgPr>
@@ -10104,7 +10737,7 @@
 </p:sld>
 </file>
 
-<file path=ppt/slides/slide21.xml><?xml version="1.0" encoding="utf-8"?>
+<file path=ppt/slides/slide22.xml><?xml version="1.0" encoding="utf-8"?>
 <p:sld xmlns:a="http://schemas.openxmlformats.org/drawingml/2006/main" xmlns:p="http://schemas.openxmlformats.org/presentationml/2006/main" xmlns:r="http://schemas.openxmlformats.org/officeDocument/2006/relationships">
   <p:cSld>
     <p:bg>
@@ -10362,7 +10995,7 @@
 </p:sld>
 </file>
 
-<file path=ppt/slides/slide22.xml><?xml version="1.0" encoding="utf-8"?>
+<file path=ppt/slides/slide23.xml><?xml version="1.0" encoding="utf-8"?>
 <p:sld xmlns:a="http://schemas.openxmlformats.org/drawingml/2006/main" xmlns:r="http://schemas.openxmlformats.org/officeDocument/2006/relationships" xmlns:p="http://schemas.openxmlformats.org/presentationml/2006/main">
   <p:cSld name="Slide 13">
     <p:bg>
@@ -10845,7 +11478,7 @@
 </p:sld>
 </file>
 
-<file path=ppt/slides/slide23.xml><?xml version="1.0" encoding="utf-8"?>
+<file path=ppt/slides/slide24.xml><?xml version="1.0" encoding="utf-8"?>
 <p:sld xmlns:a="http://schemas.openxmlformats.org/drawingml/2006/main" xmlns:p="http://schemas.openxmlformats.org/presentationml/2006/main" xmlns:r="http://schemas.openxmlformats.org/officeDocument/2006/relationships">
   <p:cSld>
     <p:bg>
@@ -11034,7 +11667,7 @@
 </p:sld>
 </file>
 
-<file path=ppt/slides/slide24.xml><?xml version="1.0" encoding="utf-8"?>
+<file path=ppt/slides/slide25.xml><?xml version="1.0" encoding="utf-8"?>
 <p:sld xmlns:a="http://schemas.openxmlformats.org/drawingml/2006/main" xmlns:r="http://schemas.openxmlformats.org/officeDocument/2006/relationships" xmlns:p="http://schemas.openxmlformats.org/presentationml/2006/main">
   <p:cSld name="Slide 14">
     <p:bg>
@@ -11369,7 +12002,7 @@
 </p:sld>
 </file>
 
-<file path=ppt/slides/slide25.xml><?xml version="1.0" encoding="utf-8"?>
+<file path=ppt/slides/slide26.xml><?xml version="1.0" encoding="utf-8"?>
 <p:sld xmlns:a="http://schemas.openxmlformats.org/drawingml/2006/main" xmlns:p="http://schemas.openxmlformats.org/presentationml/2006/main" xmlns:r="http://schemas.openxmlformats.org/officeDocument/2006/relationships">
   <p:cSld>
     <p:bg>
@@ -11568,7 +12201,7 @@
 </p:sld>
 </file>
 
-<file path=ppt/slides/slide26.xml><?xml version="1.0" encoding="utf-8"?>
+<file path=ppt/slides/slide27.xml><?xml version="1.0" encoding="utf-8"?>
 <p:sld xmlns:a="http://schemas.openxmlformats.org/drawingml/2006/main" xmlns:r="http://schemas.openxmlformats.org/officeDocument/2006/relationships" xmlns:p="http://schemas.openxmlformats.org/presentationml/2006/main">
   <p:cSld name="Slide 15">
     <p:bg>
@@ -11879,7 +12512,7 @@
 </p:sld>
 </file>
 
-<file path=ppt/slides/slide27.xml><?xml version="1.0" encoding="utf-8"?>
+<file path=ppt/slides/slide28.xml><?xml version="1.0" encoding="utf-8"?>
 <p:sld xmlns:a="http://schemas.openxmlformats.org/drawingml/2006/main" xmlns:p="http://schemas.openxmlformats.org/presentationml/2006/main" xmlns:r="http://schemas.openxmlformats.org/officeDocument/2006/relationships">
   <p:cSld>
     <p:bg>
@@ -13583,7 +14216,7 @@
                 <a:ea typeface="Calibri" pitchFamily="34" charset="-122"/>
                 <a:cs typeface="Calibri" pitchFamily="34" charset="-120"/>
               </a:rPr>
-              <a:t>moltes empreses combinen tots dos. Guarden en local les dades sensibles i les que necessiten més velocitat, i fan servir el núvol per a les còpies fora de l'empresa i per créixer quan cal.</a:t>
+              <a:t>moltes empreses combinen tots dos. Guarden en local les dades sensibles i les que necessiten més velocitat, i fan servir el núvol per a les còpies fora de l'empresa, per ampliar l'espai o la potència només quan cal i per col·laborar a distància.</a:t>
             </a:r>
             <a:endParaRPr lang="en-US" sz="1800" dirty="0"/>
           </a:p>
@@ -13597,7 +14230,7 @@
 </p:sld>
 </file>
 
-<file path=ppt/slides/slide28.xml><?xml version="1.0" encoding="utf-8"?>
+<file path=ppt/slides/slide29.xml><?xml version="1.0" encoding="utf-8"?>
 <p:sld xmlns:a="http://schemas.openxmlformats.org/drawingml/2006/main" xmlns:r="http://schemas.openxmlformats.org/officeDocument/2006/relationships" xmlns:p="http://schemas.openxmlformats.org/presentationml/2006/main">
   <p:cSld name="Slide 16">
     <p:bg>
@@ -14403,260 +15036,6 @@
               <a:t>Rendiment (latència, IOPS, throughput), disponibilitat i accessibilitat. SMART avisa abans que un disc falli.</a:t>
             </a:r>
             <a:endParaRPr lang="en-US" sz="1800" dirty="0"/>
-          </a:p>
-        </p:txBody>
-      </p:sp>
-    </p:spTree>
-  </p:cSld>
-  <p:clrMapOvr>
-    <a:masterClrMapping/>
-  </p:clrMapOvr>
-</p:sld>
-</file>
-
-<file path=ppt/slides/slide29.xml><?xml version="1.0" encoding="utf-8"?>
-<p:sld xmlns:a="http://schemas.openxmlformats.org/drawingml/2006/main" xmlns:r="http://schemas.openxmlformats.org/officeDocument/2006/relationships" xmlns:p="http://schemas.openxmlformats.org/presentationml/2006/main">
-  <p:cSld name="Slide 17">
-    <p:bg>
-      <p:bgPr>
-        <a:solidFill>
-          <a:srgbClr val="0B1B29"/>
-        </a:solidFill>
-      </p:bgPr>
-    </p:bg>
-    <p:spTree>
-      <p:nvGrpSpPr>
-        <p:cNvPr id="1" name=""/>
-        <p:cNvGrpSpPr/>
-        <p:nvPr/>
-      </p:nvGrpSpPr>
-      <p:grpSpPr>
-        <a:xfrm>
-          <a:off x="0" y="0"/>
-          <a:ext cx="0" cy="0"/>
-          <a:chOff x="0" y="0"/>
-          <a:chExt cx="0" cy="0"/>
-        </a:xfrm>
-      </p:grpSpPr>
-      <p:sp>
-        <p:nvSpPr>
-          <p:cNvPr id="2" name="Text 0"/>
-          <p:cNvSpPr txBox="1"/>
-          <p:nvPr/>
-        </p:nvSpPr>
-        <p:spPr>
-          <a:xfrm>
-            <a:off x="822960" y="1188720"/>
-            <a:ext cx="9144000" cy="365760"/>
-          </a:xfrm>
-          <a:prstGeom prst="rect">
-            <a:avLst/>
-          </a:prstGeom>
-          <a:noFill/>
-          <a:ln/>
-        </p:spPr>
-        <p:txBody>
-          <a:bodyPr wrap="square" lIns="0" tIns="0" rIns="0" bIns="0" rtlCol="0" anchor="ctr"/>
-          <a:lstStyle/>
-          <a:p>
-            <a:pPr indent="0" marL="0">
-              <a:buNone/>
-            </a:pPr>
-            <a:r>
-              <a:rPr lang="en-US" sz="1400" b="1" spc="200" kern="0" dirty="0">
-                <a:solidFill>
-                  <a:srgbClr val="F2A541"/>
-                </a:solidFill>
-                <a:latin typeface="Calibri" pitchFamily="34" charset="0"/>
-                <a:ea typeface="Calibri" pitchFamily="34" charset="-122"/>
-                <a:cs typeface="Calibri" pitchFamily="34" charset="-120"/>
-              </a:rPr>
-              <a:t>ARA ÉS EL TORN VOSTRE</a:t>
-            </a:r>
-            <a:endParaRPr lang="en-US" sz="1400" dirty="0"/>
-          </a:p>
-        </p:txBody>
-      </p:sp>
-      <p:pic>
-        <p:nvPicPr>
-          <p:cNvPr id="3" name="Image 0" descr="/tmp/claude-0/-home-user-SMX-0226-Seguretat-Informatica/cec25c9b-7e93-584a-a64a-196540977a59/scratchpad/build/icons/question_F2A541.png">    </p:cNvPr>
-          <p:cNvPicPr>
-            <a:picLocks noChangeAspect="1"/>
-          </p:cNvPicPr>
-          <p:nvPr/>
-        </p:nvPicPr>
-        <p:blipFill>
-          <a:blip r:embed="rId1"/>
-          <a:stretch>
-            <a:fillRect/>
-          </a:stretch>
-        </p:blipFill>
-        <p:spPr>
-          <a:xfrm>
-            <a:off x="9875520" y="1097280"/>
-            <a:ext cx="731520" cy="731520"/>
-          </a:xfrm>
-          <a:prstGeom prst="rect">
-            <a:avLst/>
-          </a:prstGeom>
-        </p:spPr>
-      </p:pic>
-      <p:sp>
-        <p:nvSpPr>
-          <p:cNvPr id="4" name="Text 1"/>
-          <p:cNvSpPr txBox="1"/>
-          <p:nvPr/>
-        </p:nvSpPr>
-        <p:spPr>
-          <a:xfrm>
-            <a:off x="822960" y="1737360"/>
-            <a:ext cx="10332720" cy="1463040"/>
-          </a:xfrm>
-          <a:prstGeom prst="rect">
-            <a:avLst/>
-          </a:prstGeom>
-          <a:noFill/>
-          <a:ln/>
-        </p:spPr>
-        <p:txBody>
-          <a:bodyPr wrap="square" lIns="0" tIns="0" rIns="0" bIns="0" rtlCol="0" anchor="ctr"/>
-          <a:lstStyle/>
-          <a:p>
-            <a:pPr indent="0" marL="0">
-              <a:buNone/>
-            </a:pPr>
-            <a:r>
-              <a:rPr lang="en-US" sz="2600" b="1" dirty="0">
-                <a:solidFill>
-                  <a:srgbClr val="FFFFFF"/>
-                </a:solidFill>
-                <a:latin typeface="Cambria" pitchFamily="34" charset="0"/>
-                <a:ea typeface="Cambria" pitchFamily="34" charset="-122"/>
-                <a:cs typeface="Cambria" pitchFamily="34" charset="-120"/>
-              </a:rPr>
-              <a:t>Un petit despatx d'advocats (5 persones) vol centralitzar els seus documents.</a:t>
-            </a:r>
-            <a:endParaRPr lang="en-US" sz="2600" dirty="0"/>
-          </a:p>
-        </p:txBody>
-      </p:sp>
-      <p:sp>
-        <p:nvSpPr>
-          <p:cNvPr id="5" name="Text 2"/>
-          <p:cNvSpPr txBox="1"/>
-          <p:nvPr/>
-        </p:nvSpPr>
-        <p:spPr>
-          <a:xfrm>
-            <a:off x="822960" y="3291840"/>
-            <a:ext cx="9875520" cy="1463040"/>
-          </a:xfrm>
-          <a:prstGeom prst="rect">
-            <a:avLst/>
-          </a:prstGeom>
-          <a:noFill/>
-          <a:ln/>
-        </p:spPr>
-        <p:txBody>
-          <a:bodyPr wrap="square" lIns="0" tIns="0" rIns="0" bIns="0" rtlCol="0" anchor="ctr"/>
-          <a:lstStyle/>
-          <a:p>
-            <a:pPr indent="0" marL="0">
-              <a:lnSpc>
-                <a:spcPts val="2592"/>
-              </a:lnSpc>
-              <a:buNone/>
-            </a:pPr>
-            <a:r>
-              <a:rPr lang="en-US" sz="1800" dirty="0">
-                <a:solidFill>
-                  <a:srgbClr val="CADCE8"/>
-                </a:solidFill>
-                <a:latin typeface="Calibri" pitchFamily="34" charset="0"/>
-                <a:ea typeface="Calibri" pitchFamily="34" charset="-122"/>
-                <a:cs typeface="Calibri" pitchFamily="34" charset="-120"/>
-              </a:rPr>
-              <a:t>En grups de 3: decidiu si recomanaríeu un DAS, un NAS o un servei de núvol, tenint en compte que gestionen dades de clients (confidencials) i tenen un pressupost limitat. Justifiqueu quin nivell de RAID hi aplicaríeu internament.</a:t>
-            </a:r>
-            <a:endParaRPr lang="en-US" sz="1800" dirty="0"/>
-          </a:p>
-        </p:txBody>
-      </p:sp>
-      <p:sp>
-        <p:nvSpPr>
-          <p:cNvPr id="6" name="Text 3"/>
-          <p:cNvSpPr txBox="1"/>
-          <p:nvPr/>
-        </p:nvSpPr>
-        <p:spPr>
-          <a:xfrm>
-            <a:off x="822960" y="6035040"/>
-            <a:ext cx="9144000" cy="365760"/>
-          </a:xfrm>
-          <a:prstGeom prst="rect">
-            <a:avLst/>
-          </a:prstGeom>
-          <a:noFill/>
-          <a:ln/>
-        </p:spPr>
-        <p:txBody>
-          <a:bodyPr wrap="square" lIns="0" tIns="0" rIns="0" bIns="0" rtlCol="0" anchor="ctr"/>
-          <a:lstStyle/>
-          <a:p>
-            <a:pPr indent="0" marL="0">
-              <a:buNone/>
-            </a:pPr>
-            <a:r>
-              <a:rPr lang="en-US" sz="1800" i="1" dirty="0">
-                <a:solidFill>
-                  <a:srgbClr val="8FA6B8"/>
-                </a:solidFill>
-                <a:latin typeface="Calibri" pitchFamily="34" charset="0"/>
-                <a:ea typeface="Calibri" pitchFamily="34" charset="-122"/>
-                <a:cs typeface="Calibri" pitchFamily="34" charset="-120"/>
-              </a:rPr>
-              <a:t>10 minuts en grup + posada en comú</a:t>
-            </a:r>
-            <a:endParaRPr lang="en-US" sz="1800" dirty="0"/>
-          </a:p>
-        </p:txBody>
-      </p:sp>
-      <p:sp>
-        <p:nvSpPr>
-          <p:cNvPr id="7" name="Text 4"/>
-          <p:cNvSpPr txBox="1"/>
-          <p:nvPr/>
-        </p:nvSpPr>
-        <p:spPr>
-          <a:xfrm>
-            <a:off x="11551615" y="6446520"/>
-            <a:ext cx="457200" cy="274320"/>
-          </a:xfrm>
-          <a:prstGeom prst="rect">
-            <a:avLst/>
-          </a:prstGeom>
-          <a:noFill/>
-          <a:ln/>
-        </p:spPr>
-        <p:txBody>
-          <a:bodyPr wrap="square" lIns="0" tIns="0" rIns="0" bIns="0" rtlCol="0" anchor="ctr"/>
-          <a:lstStyle/>
-          <a:p>
-            <a:pPr algn="r" indent="0" marL="0">
-              <a:buNone/>
-            </a:pPr>
-            <a:r>
-              <a:rPr lang="en-US" sz="1100" dirty="0">
-                <a:solidFill>
-                  <a:srgbClr val="5B6B77"/>
-                </a:solidFill>
-                <a:latin typeface="Calibri" pitchFamily="34" charset="0"/>
-                <a:ea typeface="Calibri" pitchFamily="34" charset="-122"/>
-                <a:cs typeface="Calibri" pitchFamily="34" charset="-120"/>
-              </a:rPr>
-              <a:t>30</a:t>
-            </a:r>
-            <a:endParaRPr lang="en-US" sz="1100" dirty="0"/>
           </a:p>
         </p:txBody>
       </p:sp>
@@ -15153,6 +15532,260 @@
 
 <file path=ppt/slides/slide30.xml><?xml version="1.0" encoding="utf-8"?>
 <p:sld xmlns:a="http://schemas.openxmlformats.org/drawingml/2006/main" xmlns:r="http://schemas.openxmlformats.org/officeDocument/2006/relationships" xmlns:p="http://schemas.openxmlformats.org/presentationml/2006/main">
+  <p:cSld name="Slide 17">
+    <p:bg>
+      <p:bgPr>
+        <a:solidFill>
+          <a:srgbClr val="0B1B29"/>
+        </a:solidFill>
+      </p:bgPr>
+    </p:bg>
+    <p:spTree>
+      <p:nvGrpSpPr>
+        <p:cNvPr id="1" name=""/>
+        <p:cNvGrpSpPr/>
+        <p:nvPr/>
+      </p:nvGrpSpPr>
+      <p:grpSpPr>
+        <a:xfrm>
+          <a:off x="0" y="0"/>
+          <a:ext cx="0" cy="0"/>
+          <a:chOff x="0" y="0"/>
+          <a:chExt cx="0" cy="0"/>
+        </a:xfrm>
+      </p:grpSpPr>
+      <p:sp>
+        <p:nvSpPr>
+          <p:cNvPr id="2" name="Text 0"/>
+          <p:cNvSpPr txBox="1"/>
+          <p:nvPr/>
+        </p:nvSpPr>
+        <p:spPr>
+          <a:xfrm>
+            <a:off x="822960" y="1188720"/>
+            <a:ext cx="9144000" cy="365760"/>
+          </a:xfrm>
+          <a:prstGeom prst="rect">
+            <a:avLst/>
+          </a:prstGeom>
+          <a:noFill/>
+          <a:ln/>
+        </p:spPr>
+        <p:txBody>
+          <a:bodyPr wrap="square" lIns="0" tIns="0" rIns="0" bIns="0" rtlCol="0" anchor="ctr"/>
+          <a:lstStyle/>
+          <a:p>
+            <a:pPr indent="0" marL="0">
+              <a:buNone/>
+            </a:pPr>
+            <a:r>
+              <a:rPr lang="en-US" sz="1400" b="1" spc="200" kern="0" dirty="0">
+                <a:solidFill>
+                  <a:srgbClr val="F2A541"/>
+                </a:solidFill>
+                <a:latin typeface="Calibri" pitchFamily="34" charset="0"/>
+                <a:ea typeface="Calibri" pitchFamily="34" charset="-122"/>
+                <a:cs typeface="Calibri" pitchFamily="34" charset="-120"/>
+              </a:rPr>
+              <a:t>ARA ÉS EL TORN VOSTRE</a:t>
+            </a:r>
+            <a:endParaRPr lang="en-US" sz="1400" dirty="0"/>
+          </a:p>
+        </p:txBody>
+      </p:sp>
+      <p:pic>
+        <p:nvPicPr>
+          <p:cNvPr id="3" name="Image 0" descr="/tmp/claude-0/-home-user-SMX-0226-Seguretat-Informatica/cec25c9b-7e93-584a-a64a-196540977a59/scratchpad/build/icons/question_F2A541.png">    </p:cNvPr>
+          <p:cNvPicPr>
+            <a:picLocks noChangeAspect="1"/>
+          </p:cNvPicPr>
+          <p:nvPr/>
+        </p:nvPicPr>
+        <p:blipFill>
+          <a:blip r:embed="rId1"/>
+          <a:stretch>
+            <a:fillRect/>
+          </a:stretch>
+        </p:blipFill>
+        <p:spPr>
+          <a:xfrm>
+            <a:off x="9875520" y="1097280"/>
+            <a:ext cx="731520" cy="731520"/>
+          </a:xfrm>
+          <a:prstGeom prst="rect">
+            <a:avLst/>
+          </a:prstGeom>
+        </p:spPr>
+      </p:pic>
+      <p:sp>
+        <p:nvSpPr>
+          <p:cNvPr id="4" name="Text 1"/>
+          <p:cNvSpPr txBox="1"/>
+          <p:nvPr/>
+        </p:nvSpPr>
+        <p:spPr>
+          <a:xfrm>
+            <a:off x="822960" y="1737360"/>
+            <a:ext cx="10332720" cy="1463040"/>
+          </a:xfrm>
+          <a:prstGeom prst="rect">
+            <a:avLst/>
+          </a:prstGeom>
+          <a:noFill/>
+          <a:ln/>
+        </p:spPr>
+        <p:txBody>
+          <a:bodyPr wrap="square" lIns="0" tIns="0" rIns="0" bIns="0" rtlCol="0" anchor="ctr"/>
+          <a:lstStyle/>
+          <a:p>
+            <a:pPr indent="0" marL="0">
+              <a:buNone/>
+            </a:pPr>
+            <a:r>
+              <a:rPr lang="en-US" sz="2600" b="1" dirty="0">
+                <a:solidFill>
+                  <a:srgbClr val="FFFFFF"/>
+                </a:solidFill>
+                <a:latin typeface="Cambria" pitchFamily="34" charset="0"/>
+                <a:ea typeface="Cambria" pitchFamily="34" charset="-122"/>
+                <a:cs typeface="Cambria" pitchFamily="34" charset="-120"/>
+              </a:rPr>
+              <a:t>Un petit despatx d'advocats (5 persones) vol centralitzar els seus documents.</a:t>
+            </a:r>
+            <a:endParaRPr lang="en-US" sz="2600" dirty="0"/>
+          </a:p>
+        </p:txBody>
+      </p:sp>
+      <p:sp>
+        <p:nvSpPr>
+          <p:cNvPr id="5" name="Text 2"/>
+          <p:cNvSpPr txBox="1"/>
+          <p:nvPr/>
+        </p:nvSpPr>
+        <p:spPr>
+          <a:xfrm>
+            <a:off x="822960" y="3291840"/>
+            <a:ext cx="9875520" cy="1463040"/>
+          </a:xfrm>
+          <a:prstGeom prst="rect">
+            <a:avLst/>
+          </a:prstGeom>
+          <a:noFill/>
+          <a:ln/>
+        </p:spPr>
+        <p:txBody>
+          <a:bodyPr wrap="square" lIns="0" tIns="0" rIns="0" bIns="0" rtlCol="0" anchor="ctr"/>
+          <a:lstStyle/>
+          <a:p>
+            <a:pPr indent="0" marL="0">
+              <a:lnSpc>
+                <a:spcPts val="2592"/>
+              </a:lnSpc>
+              <a:buNone/>
+            </a:pPr>
+            <a:r>
+              <a:rPr lang="en-US" sz="1800" dirty="0">
+                <a:solidFill>
+                  <a:srgbClr val="CADCE8"/>
+                </a:solidFill>
+                <a:latin typeface="Calibri" pitchFamily="34" charset="0"/>
+                <a:ea typeface="Calibri" pitchFamily="34" charset="-122"/>
+                <a:cs typeface="Calibri" pitchFamily="34" charset="-120"/>
+              </a:rPr>
+              <a:t>En grups de 3: decidiu si recomanaríeu un DAS, un NAS o un servei de núvol, tenint en compte que gestionen dades de clients (confidencials) i tenen un pressupost limitat. Justifiqueu quin nivell de RAID hi aplicaríeu internament.</a:t>
+            </a:r>
+            <a:endParaRPr lang="en-US" sz="1800" dirty="0"/>
+          </a:p>
+        </p:txBody>
+      </p:sp>
+      <p:sp>
+        <p:nvSpPr>
+          <p:cNvPr id="6" name="Text 3"/>
+          <p:cNvSpPr txBox="1"/>
+          <p:nvPr/>
+        </p:nvSpPr>
+        <p:spPr>
+          <a:xfrm>
+            <a:off x="822960" y="6035040"/>
+            <a:ext cx="9144000" cy="365760"/>
+          </a:xfrm>
+          <a:prstGeom prst="rect">
+            <a:avLst/>
+          </a:prstGeom>
+          <a:noFill/>
+          <a:ln/>
+        </p:spPr>
+        <p:txBody>
+          <a:bodyPr wrap="square" lIns="0" tIns="0" rIns="0" bIns="0" rtlCol="0" anchor="ctr"/>
+          <a:lstStyle/>
+          <a:p>
+            <a:pPr indent="0" marL="0">
+              <a:buNone/>
+            </a:pPr>
+            <a:r>
+              <a:rPr lang="en-US" sz="1800" i="1" dirty="0">
+                <a:solidFill>
+                  <a:srgbClr val="8FA6B8"/>
+                </a:solidFill>
+                <a:latin typeface="Calibri" pitchFamily="34" charset="0"/>
+                <a:ea typeface="Calibri" pitchFamily="34" charset="-122"/>
+                <a:cs typeface="Calibri" pitchFamily="34" charset="-120"/>
+              </a:rPr>
+              <a:t>10 minuts en grup + posada en comú</a:t>
+            </a:r>
+            <a:endParaRPr lang="en-US" sz="1800" dirty="0"/>
+          </a:p>
+        </p:txBody>
+      </p:sp>
+      <p:sp>
+        <p:nvSpPr>
+          <p:cNvPr id="7" name="Text 4"/>
+          <p:cNvSpPr txBox="1"/>
+          <p:nvPr/>
+        </p:nvSpPr>
+        <p:spPr>
+          <a:xfrm>
+            <a:off x="11551615" y="6446520"/>
+            <a:ext cx="457200" cy="274320"/>
+          </a:xfrm>
+          <a:prstGeom prst="rect">
+            <a:avLst/>
+          </a:prstGeom>
+          <a:noFill/>
+          <a:ln/>
+        </p:spPr>
+        <p:txBody>
+          <a:bodyPr wrap="square" lIns="0" tIns="0" rIns="0" bIns="0" rtlCol="0" anchor="ctr"/>
+          <a:lstStyle/>
+          <a:p>
+            <a:pPr algn="r" indent="0" marL="0">
+              <a:buNone/>
+            </a:pPr>
+            <a:r>
+              <a:rPr lang="en-US" sz="1100" dirty="0">
+                <a:solidFill>
+                  <a:srgbClr val="5B6B77"/>
+                </a:solidFill>
+                <a:latin typeface="Calibri" pitchFamily="34" charset="0"/>
+                <a:ea typeface="Calibri" pitchFamily="34" charset="-122"/>
+                <a:cs typeface="Calibri" pitchFamily="34" charset="-120"/>
+              </a:rPr>
+              <a:t>30</a:t>
+            </a:r>
+            <a:endParaRPr lang="en-US" sz="1100" dirty="0"/>
+          </a:p>
+        </p:txBody>
+      </p:sp>
+    </p:spTree>
+  </p:cSld>
+  <p:clrMapOvr>
+    <a:masterClrMapping/>
+  </p:clrMapOvr>
+</p:sld>
+</file>
+
+<file path=ppt/slides/slide31.xml><?xml version="1.0" encoding="utf-8"?>
+<p:sld xmlns:a="http://schemas.openxmlformats.org/drawingml/2006/main" xmlns:r="http://schemas.openxmlformats.org/officeDocument/2006/relationships" xmlns:p="http://schemas.openxmlformats.org/presentationml/2006/main">
   <p:cSld name="Slide 18">
     <p:bg>
       <p:bgPr>
@@ -15725,639 +16358,6 @@
               <a:t>31</a:t>
             </a:r>
             <a:endParaRPr lang="en-US" sz="1100" dirty="0"/>
-          </a:p>
-        </p:txBody>
-      </p:sp>
-    </p:spTree>
-  </p:cSld>
-  <p:clrMapOvr>
-    <a:masterClrMapping/>
-  </p:clrMapOvr>
-</p:sld>
-</file>
-
-<file path=ppt/slides/slide31.xml><?xml version="1.0" encoding="utf-8"?>
-<p:sld xmlns:a="http://schemas.openxmlformats.org/drawingml/2006/main" xmlns:p="http://schemas.openxmlformats.org/presentationml/2006/main" xmlns:r="http://schemas.openxmlformats.org/officeDocument/2006/relationships">
-  <p:cSld>
-    <p:bg>
-      <p:bgPr>
-        <a:solidFill>
-          <a:srgbClr val="F4F7F9"/>
-        </a:solidFill>
-      </p:bgPr>
-    </p:bg>
-    <p:spTree>
-      <p:nvGrpSpPr>
-        <p:cNvPr id="1" name=""/>
-        <p:cNvGrpSpPr/>
-        <p:nvPr/>
-      </p:nvGrpSpPr>
-      <p:grpSpPr/>
-      <p:sp>
-        <p:nvSpPr>
-          <p:cNvPr id="2" name="Text 0"/>
-          <p:cNvSpPr txBox="1"/>
-          <p:nvPr/>
-        </p:nvSpPr>
-        <p:spPr>
-          <a:xfrm>
-            <a:off x="548640" y="457200"/>
-            <a:ext cx="9144000" cy="365760"/>
-          </a:xfrm>
-          <a:prstGeom prst="rect">
-            <a:avLst/>
-          </a:prstGeom>
-          <a:noFill/>
-          <a:ln/>
-        </p:spPr>
-        <p:txBody>
-          <a:bodyPr wrap="square" lIns="0" tIns="0" rIns="0" bIns="0" rtlCol="0" anchor="ctr"/>
-          <a:lstStyle/>
-          <a:p>
-            <a:pPr indent="0" marL="0">
-              <a:buNone/>
-            </a:pPr>
-            <a:r>
-              <a:rPr lang="en-US" sz="1300" b="1" spc="200" kern="0" dirty="0">
-                <a:solidFill>
-                  <a:srgbClr val="F2A541"/>
-                </a:solidFill>
-                <a:latin typeface="Calibri" pitchFamily="34" charset="0"/>
-                <a:ea typeface="Calibri" pitchFamily="34" charset="-122"/>
-                <a:cs typeface="Calibri" pitchFamily="34" charset="-120"/>
-              </a:rPr>
-              <a:t>RAID 5 · LA PARITAT</a:t>
-            </a:r>
-            <a:endParaRPr lang="en-US" sz="1300" dirty="0"/>
-          </a:p>
-        </p:txBody>
-      </p:sp>
-      <p:sp>
-        <p:nvSpPr>
-          <p:cNvPr id="3" name="Text 1"/>
-          <p:cNvSpPr txBox="1"/>
-          <p:nvPr/>
-        </p:nvSpPr>
-        <p:spPr>
-          <a:xfrm>
-            <a:off x="548640" y="822960"/>
-            <a:ext cx="10789920" cy="640080"/>
-          </a:xfrm>
-          <a:prstGeom prst="rect">
-            <a:avLst/>
-          </a:prstGeom>
-          <a:noFill/>
-          <a:ln/>
-        </p:spPr>
-        <p:txBody>
-          <a:bodyPr wrap="square" lIns="0" tIns="0" rIns="0" bIns="0" rtlCol="0" anchor="ctr"/>
-          <a:lstStyle/>
-          <a:p>
-            <a:pPr indent="0" marL="0">
-              <a:buNone/>
-            </a:pPr>
-            <a:r>
-              <a:rPr lang="en-US" sz="2800" b="1" dirty="0">
-                <a:solidFill>
-                  <a:srgbClr val="16242E"/>
-                </a:solidFill>
-                <a:latin typeface="Cambria" pitchFamily="34" charset="0"/>
-                <a:ea typeface="Cambria" pitchFamily="34" charset="-122"/>
-                <a:cs typeface="Cambria" pitchFamily="34" charset="-120"/>
-              </a:rPr>
-              <a:t>Com funciona la paritat?</a:t>
-            </a:r>
-            <a:endParaRPr lang="en-US" sz="2800" dirty="0"/>
-          </a:p>
-        </p:txBody>
-      </p:sp>
-      <p:sp>
-        <p:nvSpPr>
-          <p:cNvPr id="4" name="Text 2"/>
-          <p:cNvSpPr txBox="1"/>
-          <p:nvPr/>
-        </p:nvSpPr>
-        <p:spPr>
-          <a:xfrm>
-            <a:off x="11551615" y="6446520"/>
-            <a:ext cx="457200" cy="274320"/>
-          </a:xfrm>
-          <a:prstGeom prst="rect">
-            <a:avLst/>
-          </a:prstGeom>
-          <a:noFill/>
-          <a:ln/>
-        </p:spPr>
-        <p:txBody>
-          <a:bodyPr wrap="square" lIns="0" tIns="0" rIns="0" bIns="0" rtlCol="0" anchor="ctr"/>
-          <a:lstStyle/>
-          <a:p>
-            <a:pPr algn="r" indent="0" marL="0">
-              <a:buNone/>
-            </a:pPr>
-            <a:r>
-              <a:rPr lang="en-US" sz="1100" dirty="0">
-                <a:solidFill>
-                  <a:srgbClr val="5B6B77"/>
-                </a:solidFill>
-                <a:latin typeface="Calibri" pitchFamily="34" charset="0"/>
-                <a:ea typeface="Calibri" pitchFamily="34" charset="-122"/>
-                <a:cs typeface="Calibri" pitchFamily="34" charset="-120"/>
-              </a:rPr>
-              <a:t>16</a:t>
-            </a:r>
-            <a:endParaRPr lang="en-US" sz="1100" dirty="0"/>
-          </a:p>
-        </p:txBody>
-      </p:sp>
-      <p:sp>
-        <p:nvSpPr>
-          <p:cNvPr id="5" name="Shape 3"/>
-          <p:cNvSpPr/>
-          <p:nvPr/>
-        </p:nvSpPr>
-        <p:spPr>
-          <a:xfrm>
-            <a:off x="655168" y="1661160"/>
-            <a:ext cx="5212080" cy="4279392"/>
-          </a:xfrm>
-          <a:prstGeom prst="roundRect">
-            <a:avLst>
-              <a:gd name="adj" fmla="val 2791"/>
-            </a:avLst>
-          </a:prstGeom>
-          <a:solidFill>
-            <a:srgbClr val="FFFFFF"/>
-          </a:solidFill>
-          <a:ln w="12700">
-            <a:solidFill>
-              <a:srgbClr val="E2E8ED"/>
-            </a:solidFill>
-            <a:prstDash val="solid"/>
-          </a:ln>
-          <a:effectLst>
-            <a:outerShdw sx="100000" sy="100000" kx="0" ky="0" algn="bl" rotWithShape="0" blurRad="101600" dist="38100" dir="5400000">
-              <a:srgbClr val="16242E">
-                <a:alpha val="12000"/>
-              </a:srgbClr>
-            </a:outerShdw>
-          </a:effectLst>
-        </p:spPr>
-        <p:txBody>
-          <a:bodyPr/>
-          <a:p/>
-        </p:txBody>
-      </p:sp>
-      <p:sp>
-        <p:nvSpPr>
-          <p:cNvPr id="6" name="Shape 4"/>
-          <p:cNvSpPr/>
-          <p:nvPr/>
-        </p:nvSpPr>
-        <p:spPr>
-          <a:xfrm>
-            <a:off x="1039216" y="2045208"/>
-            <a:ext cx="731520" cy="731520"/>
-          </a:xfrm>
-          <a:prstGeom prst="ellipse">
-            <a:avLst/>
-          </a:prstGeom>
-          <a:solidFill>
-            <a:srgbClr val="0B1B29"/>
-          </a:solidFill>
-          <a:ln/>
-        </p:spPr>
-        <p:txBody>
-          <a:bodyPr/>
-          <a:p/>
-        </p:txBody>
-      </p:sp>
-      <p:pic>
-        <p:nvPicPr>
-          <p:cNvPr id="7" name="Image 0" descr="/tmp/claude-0/-home-user-SMX-0226-Seguretat-Informatica/a92ac1fc-9241-54c9-9c87-68470d7a571f/scratchpad/aa2/icon_heartbeat.png">    </p:cNvPr>
-          <p:cNvPicPr>
-            <a:picLocks noChangeAspect="1"/>
-          </p:cNvPicPr>
-          <p:nvPr/>
-        </p:nvPicPr>
-        <p:blipFill>
-          <a:blip r:embed="rId4"/>
-          <a:stretch>
-            <a:fillRect/>
-          </a:stretch>
-        </p:blipFill>
-        <p:spPr>
-          <a:xfrm>
-            <a:off x="1203808" y="2209800"/>
-            <a:ext cx="402336" cy="402336"/>
-          </a:xfrm>
-          <a:prstGeom prst="rect">
-            <a:avLst/>
-          </a:prstGeom>
-        </p:spPr>
-      </p:pic>
-      <p:sp>
-        <p:nvSpPr>
-          <p:cNvPr id="8" name="Text 5"/>
-          <p:cNvSpPr txBox="1"/>
-          <p:nvPr/>
-        </p:nvSpPr>
-        <p:spPr>
-          <a:xfrm>
-            <a:off x="1999336" y="2243328"/>
-            <a:ext cx="3483864" cy="335280"/>
-          </a:xfrm>
-          <a:prstGeom prst="rect">
-            <a:avLst/>
-          </a:prstGeom>
-          <a:noFill/>
-          <a:ln/>
-        </p:spPr>
-        <p:txBody>
-          <a:bodyPr wrap="square" lIns="0" tIns="0" rIns="0" bIns="0" rtlCol="0" anchor="ctr"/>
-          <a:lstStyle/>
-          <a:p>
-            <a:pPr indent="0" marL="0">
-              <a:buNone/>
-            </a:pPr>
-            <a:r>
-              <a:rPr lang="en-US" sz="2200" b="1" dirty="0">
-                <a:solidFill>
-                  <a:srgbClr val="16242E"/>
-                </a:solidFill>
-                <a:latin typeface="Cambria" pitchFamily="34" charset="0"/>
-                <a:ea typeface="Cambria" pitchFamily="34" charset="-122"/>
-                <a:cs typeface="Cambria" pitchFamily="34" charset="-120"/>
-              </a:rPr>
-              <a:t>Analogia amb sumes</a:t>
-            </a:r>
-            <a:endParaRPr lang="en-US" sz="2200" dirty="0"/>
-          </a:p>
-        </p:txBody>
-      </p:sp>
-      <p:sp>
-        <p:nvSpPr>
-          <p:cNvPr id="9" name="Text 6"/>
-          <p:cNvSpPr txBox="1"/>
-          <p:nvPr/>
-        </p:nvSpPr>
-        <p:spPr>
-          <a:xfrm>
-            <a:off x="1039216" y="3069336"/>
-            <a:ext cx="4443984" cy="2176272"/>
-          </a:xfrm>
-          <a:prstGeom prst="rect">
-            <a:avLst/>
-          </a:prstGeom>
-          <a:noFill/>
-          <a:ln/>
-        </p:spPr>
-        <p:txBody>
-          <a:bodyPr wrap="square" lIns="0" tIns="0" rIns="0" bIns="0" rtlCol="0" anchor="t"/>
-          <a:lstStyle/>
-          <a:p>
-            <a:pPr indent="0" marL="0">
-              <a:lnSpc>
-                <a:spcPts val="2448"/>
-              </a:lnSpc>
-              <a:buNone/>
-            </a:pPr>
-            <a:r>
-              <a:rPr lang="en-US" sz="1800" dirty="0" b="0">
-                <a:solidFill>
-                  <a:srgbClr val="5B6B77"/>
-                </a:solidFill>
-                <a:latin typeface="Calibri" pitchFamily="34" charset="0"/>
-                <a:ea typeface="Calibri" pitchFamily="34" charset="-122"/>
-                <a:cs typeface="Calibri" pitchFamily="34" charset="-120"/>
-              </a:rPr>
-              <a:t>Caixa A = 3, caixa B = 5 i, a la caixa C, la paritat: 3 + 5 = 8.</a:t>
-            </a:r>
-            <a:endParaRPr lang="en-US" sz="1800" dirty="0"/>
-          </a:p>
-          <a:p>
-            <a:pPr indent="0" marL="0">
-              <a:lnSpc>
-                <a:spcPts val="2448"/>
-              </a:lnSpc>
-              <a:buNone/>
-            </a:pPr>
-            <a:r>
-              <a:rPr lang="en-US" sz="1800" dirty="0" b="0">
-                <a:solidFill>
-                  <a:srgbClr val="5B6B77"/>
-                </a:solidFill>
-                <a:latin typeface="Calibri" pitchFamily="34" charset="0"/>
-                <a:ea typeface="Calibri" pitchFamily="34" charset="-122"/>
-                <a:cs typeface="Calibri" pitchFamily="34" charset="-120"/>
-              </a:rPr>
-              <a:t>Es perd A → 8 − 5 = 3</a:t>
-            </a:r>
-            <a:endParaRPr lang="en-US" sz="1800" dirty="0"/>
-          </a:p>
-          <a:p>
-            <a:pPr indent="0" marL="0">
-              <a:lnSpc>
-                <a:spcPts val="2448"/>
-              </a:lnSpc>
-              <a:buNone/>
-            </a:pPr>
-            <a:r>
-              <a:rPr lang="en-US" sz="1800" dirty="0" b="0">
-                <a:solidFill>
-                  <a:srgbClr val="5B6B77"/>
-                </a:solidFill>
-                <a:latin typeface="Calibri" pitchFamily="34" charset="0"/>
-                <a:ea typeface="Calibri" pitchFamily="34" charset="-122"/>
-                <a:cs typeface="Calibri" pitchFamily="34" charset="-120"/>
-              </a:rPr>
-              <a:t>Es perd B → 8 − 3 = 5</a:t>
-            </a:r>
-            <a:endParaRPr lang="en-US" sz="1800" dirty="0"/>
-          </a:p>
-          <a:p>
-            <a:pPr indent="0" marL="0">
-              <a:lnSpc>
-                <a:spcPts val="2448"/>
-              </a:lnSpc>
-              <a:buNone/>
-            </a:pPr>
-            <a:r>
-              <a:rPr lang="en-US" sz="1800" dirty="0" b="0">
-                <a:solidFill>
-                  <a:srgbClr val="5B6B77"/>
-                </a:solidFill>
-                <a:latin typeface="Calibri" pitchFamily="34" charset="0"/>
-                <a:ea typeface="Calibri" pitchFamily="34" charset="-122"/>
-                <a:cs typeface="Calibri" pitchFamily="34" charset="-120"/>
-              </a:rPr>
-              <a:t>Es perd C → 3 + 5 = 8</a:t>
-            </a:r>
-            <a:endParaRPr lang="en-US" sz="1800" dirty="0"/>
-          </a:p>
-          <a:p>
-            <a:pPr indent="0" marL="0">
-              <a:lnSpc>
-                <a:spcPts val="2448"/>
-              </a:lnSpc>
-              <a:buNone/>
-            </a:pPr>
-            <a:r>
-              <a:rPr lang="en-US" sz="1800" dirty="0" b="1">
-                <a:solidFill>
-                  <a:srgbClr val="5B6B77"/>
-                </a:solidFill>
-                <a:latin typeface="Calibri" pitchFamily="34" charset="0"/>
-                <a:ea typeface="Calibri" pitchFamily="34" charset="-122"/>
-                <a:cs typeface="Calibri" pitchFamily="34" charset="-120"/>
-              </a:rPr>
-              <a:t>Es perden dues caixes → impossible: el RAID 5 només suporta 1 fallada.</a:t>
-            </a:r>
-            <a:endParaRPr lang="en-US" sz="1800" dirty="0"/>
-          </a:p>
-        </p:txBody>
-      </p:sp>
-      <p:sp>
-        <p:nvSpPr>
-          <p:cNvPr id="10" name="Shape 7"/>
-          <p:cNvSpPr/>
-          <p:nvPr/>
-        </p:nvSpPr>
-        <p:spPr>
-          <a:xfrm>
-            <a:off x="6324448" y="1661160"/>
-            <a:ext cx="5212080" cy="4279392"/>
-          </a:xfrm>
-          <a:prstGeom prst="roundRect">
-            <a:avLst>
-              <a:gd name="adj" fmla="val 2791"/>
-            </a:avLst>
-          </a:prstGeom>
-          <a:solidFill>
-            <a:srgbClr val="FFFFFF"/>
-          </a:solidFill>
-          <a:ln w="12700">
-            <a:solidFill>
-              <a:srgbClr val="E2E8ED"/>
-            </a:solidFill>
-            <a:prstDash val="solid"/>
-          </a:ln>
-          <a:effectLst>
-            <a:outerShdw sx="100000" sy="100000" kx="0" ky="0" algn="bl" rotWithShape="0" blurRad="101600" dist="38100" dir="5400000">
-              <a:srgbClr val="16242E">
-                <a:alpha val="12000"/>
-              </a:srgbClr>
-            </a:outerShdw>
-          </a:effectLst>
-        </p:spPr>
-        <p:txBody>
-          <a:bodyPr/>
-          <a:p/>
-        </p:txBody>
-      </p:sp>
-      <p:sp>
-        <p:nvSpPr>
-          <p:cNvPr id="11" name="Shape 8"/>
-          <p:cNvSpPr/>
-          <p:nvPr/>
-        </p:nvSpPr>
-        <p:spPr>
-          <a:xfrm>
-            <a:off x="6708496" y="2045208"/>
-            <a:ext cx="731520" cy="731520"/>
-          </a:xfrm>
-          <a:prstGeom prst="ellipse">
-            <a:avLst/>
-          </a:prstGeom>
-          <a:solidFill>
-            <a:srgbClr val="0B1B29"/>
-          </a:solidFill>
-          <a:ln/>
-        </p:spPr>
-        <p:txBody>
-          <a:bodyPr/>
-          <a:p/>
-        </p:txBody>
-      </p:sp>
-      <p:pic>
-        <p:nvPicPr>
-          <p:cNvPr id="12" name="Image 1" descr="/tmp/claude-0/-home-user-SMX-0226-Seguretat-Informatica/a92ac1fc-9241-54c9-9c87-68470d7a571f/scratchpad/aa2/icon_terminal.png">    </p:cNvPr>
-          <p:cNvPicPr>
-            <a:picLocks noChangeAspect="1"/>
-          </p:cNvPicPr>
-          <p:nvPr/>
-        </p:nvPicPr>
-        <p:blipFill>
-          <a:blip r:embed="rId3"/>
-          <a:stretch>
-            <a:fillRect/>
-          </a:stretch>
-        </p:blipFill>
-        <p:spPr>
-          <a:xfrm>
-            <a:off x="6873087" y="2209800"/>
-            <a:ext cx="402336" cy="402336"/>
-          </a:xfrm>
-          <a:prstGeom prst="rect">
-            <a:avLst/>
-          </a:prstGeom>
-        </p:spPr>
-      </p:pic>
-      <p:sp>
-        <p:nvSpPr>
-          <p:cNvPr id="13" name="Text 9"/>
-          <p:cNvSpPr txBox="1"/>
-          <p:nvPr/>
-        </p:nvSpPr>
-        <p:spPr>
-          <a:xfrm>
-            <a:off x="7668616" y="2243328"/>
-            <a:ext cx="3483864" cy="335280"/>
-          </a:xfrm>
-          <a:prstGeom prst="rect">
-            <a:avLst/>
-          </a:prstGeom>
-          <a:noFill/>
-          <a:ln/>
-        </p:spPr>
-        <p:txBody>
-          <a:bodyPr wrap="square" lIns="0" tIns="0" rIns="0" bIns="0" rtlCol="0" anchor="ctr"/>
-          <a:lstStyle/>
-          <a:p>
-            <a:pPr indent="0" marL="0">
-              <a:buNone/>
-            </a:pPr>
-            <a:r>
-              <a:rPr lang="en-US" sz="2200" b="1" dirty="0">
-                <a:solidFill>
-                  <a:srgbClr val="16242E"/>
-                </a:solidFill>
-                <a:latin typeface="Cambria" pitchFamily="34" charset="0"/>
-                <a:ea typeface="Cambria" pitchFamily="34" charset="-122"/>
-                <a:cs typeface="Cambria" pitchFamily="34" charset="-120"/>
-              </a:rPr>
-              <a:t>Amb bits: l'operació XOR</a:t>
-            </a:r>
-            <a:endParaRPr lang="en-US" sz="2200" dirty="0"/>
-          </a:p>
-        </p:txBody>
-      </p:sp>
-      <p:sp>
-        <p:nvSpPr>
-          <p:cNvPr id="14" name="Text 10"/>
-          <p:cNvSpPr txBox="1"/>
-          <p:nvPr/>
-        </p:nvSpPr>
-        <p:spPr>
-          <a:xfrm>
-            <a:off x="6708496" y="3069336"/>
-            <a:ext cx="4443984" cy="2487168"/>
-          </a:xfrm>
-          <a:prstGeom prst="rect">
-            <a:avLst/>
-          </a:prstGeom>
-          <a:noFill/>
-          <a:ln/>
-        </p:spPr>
-        <p:txBody>
-          <a:bodyPr wrap="square" lIns="0" tIns="0" rIns="0" bIns="0" rtlCol="0" anchor="t"/>
-          <a:lstStyle/>
-          <a:p>
-            <a:pPr indent="0" marL="0">
-              <a:lnSpc>
-                <a:spcPts val="2448"/>
-              </a:lnSpc>
-              <a:buNone/>
-            </a:pPr>
-            <a:r>
-              <a:rPr lang="en-US" sz="1800" dirty="0" b="0">
-                <a:solidFill>
-                  <a:srgbClr val="5B6B77"/>
-                </a:solidFill>
-                <a:ea typeface="Calibri" pitchFamily="34" charset="-122"/>
-                <a:latin typeface="Consolas"/>
-              </a:rPr>
-              <a:t>Disc 1:   1 0 1 1</a:t>
-            </a:r>
-            <a:endParaRPr lang="en-US" sz="1800" dirty="0"/>
-          </a:p>
-          <a:p>
-            <a:pPr indent="0" marL="0">
-              <a:lnSpc>
-                <a:spcPts val="2448"/>
-              </a:lnSpc>
-              <a:buNone/>
-            </a:pPr>
-            <a:r>
-              <a:rPr lang="en-US" sz="1800" dirty="0" b="0">
-                <a:solidFill>
-                  <a:srgbClr val="5B6B77"/>
-                </a:solidFill>
-                <a:ea typeface="Calibri" pitchFamily="34" charset="-122"/>
-                <a:latin typeface="Consolas"/>
-              </a:rPr>
-              <a:t>Disc 2:   0 1 1 0</a:t>
-            </a:r>
-            <a:endParaRPr lang="en-US" sz="1800" dirty="0"/>
-          </a:p>
-          <a:p>
-            <a:pPr indent="0" marL="0">
-              <a:lnSpc>
-                <a:spcPts val="2448"/>
-              </a:lnSpc>
-              <a:buNone/>
-            </a:pPr>
-            <a:r>
-              <a:rPr lang="en-US" sz="1800" dirty="0" b="1">
-                <a:solidFill>
-                  <a:srgbClr val="5B6B77"/>
-                </a:solidFill>
-                <a:ea typeface="Calibri" pitchFamily="34" charset="-122"/>
-                <a:latin typeface="Consolas"/>
-              </a:rPr>
-              <a:t>Paritat:  1 1 0 1</a:t>
-            </a:r>
-            <a:endParaRPr lang="en-US" sz="1800" dirty="0"/>
-          </a:p>
-          <a:p>
-            <a:pPr indent="0" marL="0">
-              <a:lnSpc>
-                <a:spcPts val="2448"/>
-              </a:lnSpc>
-              <a:buNone/>
-            </a:pPr>
-            <a:r>
-              <a:rPr lang="en-US" sz="1800" dirty="0" b="0">
-                <a:solidFill>
-                  <a:srgbClr val="5B6B77"/>
-                </a:solidFill>
-                <a:latin typeface="Calibri" pitchFamily="34" charset="0"/>
-                <a:ea typeface="Calibri" pitchFamily="34" charset="-122"/>
-                <a:cs typeface="Calibri" pitchFamily="34" charset="-120"/>
-              </a:rPr>
-              <a:t>XOR: 1 si els bits són diferents, 0 si són iguals.</a:t>
-            </a:r>
-            <a:endParaRPr lang="en-US" sz="1800" dirty="0"/>
-          </a:p>
-          <a:p>
-            <a:pPr indent="0" marL="0">
-              <a:lnSpc>
-                <a:spcPts val="2448"/>
-              </a:lnSpc>
-              <a:buNone/>
-            </a:pPr>
-            <a:r>
-              <a:rPr lang="en-US" sz="1800" dirty="0" b="1">
-                <a:solidFill>
-                  <a:srgbClr val="5B6B77"/>
-                </a:solidFill>
-                <a:latin typeface="Calibri" pitchFamily="34" charset="0"/>
-                <a:ea typeface="Calibri" pitchFamily="34" charset="-122"/>
-                <a:cs typeface="Calibri" pitchFamily="34" charset="-120"/>
-              </a:rPr>
-              <a:t>Si falla el disc 1: disc 2 XOR paritat = 1 0 1 1 → recuperat.</a:t>
-            </a:r>
-            <a:endParaRPr lang="en-US" sz="1800" dirty="0"/>
           </a:p>
         </p:txBody>
       </p:sp>

</xml_diff>